<commit_message>
Fill deck with final-run metrics and MSFT deep-dive, remove placeholders
</commit_message>
<xml_diff>
--- a/presentation/portfolio-pitch.pptx
+++ b/presentation/portfolio-pitch.pptx
@@ -574,7 +574,7 @@
           <a:lstStyle/>
           <a:p>
             <a:r>
-              <a:t>~1:40. One sentence on the pipeline, one per analyst if time. Then open ONE decision, picked by largest disagreement, not by which analyst won. Fill the [placeholders] from the final run first. Stress traceability: sources and the validator, not vibes.</a:t>
+              <a:t>~1:40. One sentence on the pipeline, one per analyst if time. Then open ONE decision: MSFT is the most contested (spread 0.78) - technical bearish (-0.85) on a weak trend, fundamentals bullish (+0.90) on growth/margins. Manager sized it to 8% rather than cutting. Picked by largest disagreement, not by which analyst won. Stress traceability: sources and the validator, not vibes.</a:t>
             </a:r>
           </a:p>
         </p:txBody>
@@ -644,7 +644,7 @@
           <a:lstStyle/>
           <a:p>
             <a:r>
-              <a:t>~1:00. Walk the metrics table vs both baselines (fill before presenting), add contribution by position if built. Close on credibility: leakage test, cached reproducible run, limitations. Stretch items are 'what's next' — only show as results once actually built.</a:t>
+              <a:t>~1:00. Portfolio 16.7% vs SPY 11.2% vs equal weight 15.5%, Sharpe 2.37 and the shallowest drawdown (-5.3%). Honest line: beats SPY in 5/5 uncached runs, beats equal weight in only 3/5 - say it's statistically close to equal weight, not a clear win. Top contributors AAPL and XOM. Close on credibility: leakage test, cached reproducible run, limitations (model memory, 180-day window). Risk management and CrashLab are built/in progress - frame as what's next.</a:t>
             </a:r>
           </a:p>
         </p:txBody>
@@ -5158,7 +5158,7 @@
                 </a:solidFill>
                 <a:latin typeface="Segoe UI"/>
               </a:rPr>
-              <a:t>[TICKER]</a:t>
+              <a:t>MSFT</a:t>
             </a:r>
             <a:r>
               <a:rPr sz="1200" b="0" i="0">
@@ -5167,7 +5167,7 @@
                 </a:solidFill>
                 <a:latin typeface="Segoe UI"/>
               </a:rPr>
-              <a:t>  deep-dive position</a:t>
+              <a:t>  most contested (spread 0.78)</a:t>
             </a:r>
           </a:p>
           <a:p>
@@ -5192,7 +5192,7 @@
                 </a:solidFill>
                 <a:latin typeface="Segoe UI"/>
               </a:rPr>
-              <a:t>[stance]</a:t>
+              <a:t>-0.85</a:t>
             </a:r>
             <a:r>
               <a:rPr sz="1300" b="0" i="0">
@@ -5210,7 +5210,7 @@
                 </a:solidFill>
                 <a:latin typeface="Segoe UI"/>
               </a:rPr>
-              <a:t>[stance]</a:t>
+              <a:t>+0.90</a:t>
             </a:r>
           </a:p>
           <a:p>
@@ -5235,7 +5235,7 @@
                 </a:solidFill>
                 <a:latin typeface="Segoe UI"/>
               </a:rPr>
-              <a:t>[what they disagreed on]</a:t>
+              <a:t>weak price trend vs strong growth &amp; margins</a:t>
             </a:r>
           </a:p>
           <a:p>
@@ -5260,7 +5260,7 @@
                 </a:solidFill>
                 <a:latin typeface="Segoe UI"/>
               </a:rPr>
-              <a:t>[weight]</a:t>
+              <a:t>8%</a:t>
             </a:r>
             <a:r>
               <a:rPr sz="1300" b="0" i="0">
@@ -5269,16 +5269,7 @@
                 </a:solidFill>
                 <a:latin typeface="Segoe UI"/>
               </a:rPr>
-              <a:t> because </a:t>
-            </a:r>
-            <a:r>
-              <a:rPr sz="1300" b="0" i="0">
-                <a:solidFill>
-                  <a:srgbClr val="F2C45A"/>
-                </a:solidFill>
-                <a:latin typeface="Segoe UI"/>
-              </a:rPr>
-              <a:t>[one line]</a:t>
+              <a:t> — sized down, not cut, until the trend confirms</a:t>
             </a:r>
           </a:p>
         </p:txBody>
@@ -5718,7 +5709,7 @@
                           </a:solidFill>
                           <a:latin typeface="Segoe UI"/>
                         </a:rPr>
-                        <a:t>[  _  ]</a:t>
+                        <a:t>16.7%</a:t>
                       </a:r>
                     </a:p>
                   </a:txBody>
@@ -5737,11 +5728,11 @@
                       <a:r>
                         <a:rPr sz="1300" b="0" i="0">
                           <a:solidFill>
-                            <a:srgbClr val="F2C45A"/>
+                            <a:srgbClr val="EAF1F8"/>
                           </a:solidFill>
                           <a:latin typeface="Segoe UI"/>
                         </a:rPr>
-                        <a:t>[  _  ]</a:t>
+                        <a:t>11.2%</a:t>
                       </a:r>
                     </a:p>
                   </a:txBody>
@@ -5760,11 +5751,11 @@
                       <a:r>
                         <a:rPr sz="1300" b="0" i="0">
                           <a:solidFill>
-                            <a:srgbClr val="F2C45A"/>
+                            <a:srgbClr val="EAF1F8"/>
                           </a:solidFill>
                           <a:latin typeface="Segoe UI"/>
                         </a:rPr>
-                        <a:t>[  _  ]</a:t>
+                        <a:t>15.5%</a:t>
                       </a:r>
                     </a:p>
                   </a:txBody>
@@ -5812,7 +5803,7 @@
                           </a:solidFill>
                           <a:latin typeface="Segoe UI"/>
                         </a:rPr>
-                        <a:t>[  _  ]</a:t>
+                        <a:t>2.37</a:t>
                       </a:r>
                     </a:p>
                   </a:txBody>
@@ -5831,11 +5822,11 @@
                       <a:r>
                         <a:rPr sz="1300" b="0" i="0">
                           <a:solidFill>
-                            <a:srgbClr val="F2C45A"/>
+                            <a:srgbClr val="EAF1F8"/>
                           </a:solidFill>
                           <a:latin typeface="Segoe UI"/>
                         </a:rPr>
-                        <a:t>[  _  ]</a:t>
+                        <a:t>1.19</a:t>
                       </a:r>
                     </a:p>
                   </a:txBody>
@@ -5854,11 +5845,11 @@
                       <a:r>
                         <a:rPr sz="1300" b="0" i="0">
                           <a:solidFill>
-                            <a:srgbClr val="F2C45A"/>
+                            <a:srgbClr val="EAF1F8"/>
                           </a:solidFill>
                           <a:latin typeface="Segoe UI"/>
                         </a:rPr>
-                        <a:t>[  _  ]</a:t>
+                        <a:t>2.02</a:t>
                       </a:r>
                     </a:p>
                   </a:txBody>
@@ -5906,7 +5897,7 @@
                           </a:solidFill>
                           <a:latin typeface="Segoe UI"/>
                         </a:rPr>
-                        <a:t>[  _  ]</a:t>
+                        <a:t>-5.3%</a:t>
                       </a:r>
                     </a:p>
                   </a:txBody>
@@ -5925,11 +5916,11 @@
                       <a:r>
                         <a:rPr sz="1300" b="0" i="0">
                           <a:solidFill>
-                            <a:srgbClr val="F2C45A"/>
+                            <a:srgbClr val="EAF1F8"/>
                           </a:solidFill>
                           <a:latin typeface="Segoe UI"/>
                         </a:rPr>
-                        <a:t>[  _  ]</a:t>
+                        <a:t>-8.9%</a:t>
                       </a:r>
                     </a:p>
                   </a:txBody>
@@ -5948,11 +5939,11 @@
                       <a:r>
                         <a:rPr sz="1300" b="0" i="0">
                           <a:solidFill>
-                            <a:srgbClr val="F2C45A"/>
+                            <a:srgbClr val="EAF1F8"/>
                           </a:solidFill>
                           <a:latin typeface="Segoe UI"/>
                         </a:rPr>
-                        <a:t>[  _  ]</a:t>
+                        <a:t>-6.1%</a:t>
                       </a:r>
                     </a:p>
                   </a:txBody>
@@ -6001,7 +5992,7 @@
                 </a:solidFill>
                 <a:latin typeface="Segoe UI"/>
               </a:rPr>
-              <a:t>Fill from the final cached run. Beating the market isn't required — explaining the result and testing it against the baselines is the point.</a:t>
+              <a:t>Beats SPY on every measure, statistically close to equal weight. Beating the market isn't required - explaining the result and testing it against the baselines is.</a:t>
             </a:r>
           </a:p>
         </p:txBody>

</xml_diff>

<commit_message>
Rework deck: AWS dark theme, wordier content, 5 slides with CrashLab and scorecard
</commit_message>
<xml_diff>
--- a/presentation/portfolio-pitch.pptx
+++ b/presentation/portfolio-pitch.pptx
@@ -6,8 +6,10 @@
   </p:sldMasterIdLst>
   <p:sldIdLst>
     <p:sldId id="256" r:id="rId7"/>
-    <p:sldId id="257" r:id="rId9"/>
-    <p:sldId id="258" r:id="rId10"/>
+    <p:sldId id="257" r:id="rId8"/>
+    <p:sldId id="258" r:id="rId9"/>
+    <p:sldId id="259" r:id="rId10"/>
+    <p:sldId id="260" r:id="rId11"/>
   </p:sldIdLst>
   <p:sldSz cx="12191695" cy="6858000" type="screen4x3"/>
   <p:notesSz cx="6858000" cy="9144000"/>
@@ -504,7 +506,7 @@
           <a:lstStyle/>
           <a:p>
             <a:r>
-              <a:t>20s. Say what it is and that it's a historical experiment, not advice. Point at the four cards: universe, cutoff, end date, baselines. One line on the point-in-time guard so judges know there's no look-ahead.</a:t>
+              <a:t>~25s. Historical experiment, not advice. The chips are the headline: 16.7% return, Sharpe 2.37, -5.3% drawdown, beats SPY in all five uncached runs. Mention it runs on AWS Bedrock + AgentCore.</a:t>
             </a:r>
           </a:p>
         </p:txBody>
@@ -574,7 +576,7 @@
           <a:lstStyle/>
           <a:p>
             <a:r>
-              <a:t>~1:40. One sentence on the pipeline, one per analyst if time. Then open ONE decision: MSFT is the most contested (spread 0.78) - technical bearish (-0.85) on a weak trend, fundamentals bullish (+0.90) on growth/margins. Manager sized it to 8% rather than cutting. Picked by largest disagreement, not by which analyst won. Stress traceability: sources and the validator, not vibes.</a:t>
+              <a:t>~40s. One line on the valve, one per lane. Then the three rules: no peeking (leakage test), show the sources (validator), score once (cache + one final run).</a:t>
             </a:r>
           </a:p>
         </p:txBody>
@@ -644,7 +646,147 @@
           <a:lstStyle/>
           <a:p>
             <a:r>
-              <a:t>~1:00. Portfolio 16.7% vs SPY 11.2% vs equal weight 15.5%, Sharpe 2.37 and the shallowest drawdown (-5.3%). Honest line: beats SPY in 5/5 uncached runs, beats equal weight in only 3/5 - say it's statistically close to equal weight, not a clear win. Top contributors AAPL and XOM. Close on credibility: leakage test, cached reproducible run, limitations (model memory, 180-day window). Risk management and CrashLab are built/in progress - frame as what's next.</a:t>
+              <a:t>~45s. MSFT chosen by rule (widest disagreement, spread 0.78). Fundamentals +0.90 vs technical -0.85. Manager underweights to 8% rather than cutting; cash absorbs the uncertainty. Every figure is a cited, validated ID.</a:t>
+            </a:r>
+          </a:p>
+        </p:txBody>
+      </p:sp>
+      <p:sp>
+        <p:nvSpPr>
+          <p:cNvPr id="4" name="Slide Number Placeholder 3"/>
+          <p:cNvSpPr>
+            <a:spLocks noGrp="1"/>
+          </p:cNvSpPr>
+          <p:nvPr>
+            <p:ph type="sldNum" idx="5" sz="quarter"/>
+          </p:nvPr>
+        </p:nvSpPr>
+        <p:spPr/>
+      </p:sp>
+    </p:spTree>
+  </p:cSld>
+  <p:clrMapOvr>
+    <a:masterClrMapping/>
+  </p:clrMapOvr>
+</p:notes>
+</file>
+
+<file path=ppt/notesSlides/notesSlide4.xml><?xml version="1.0" encoding="utf-8"?>
+<p:notes xmlns:a="http://schemas.openxmlformats.org/drawingml/2006/main" xmlns:p="http://schemas.openxmlformats.org/presentationml/2006/main" xmlns:r="http://schemas.openxmlformats.org/officeDocument/2006/relationships">
+  <p:cSld>
+    <p:spTree>
+      <p:nvGrpSpPr>
+        <p:cNvPr id="1" name=""/>
+        <p:cNvGrpSpPr/>
+        <p:nvPr/>
+      </p:nvGrpSpPr>
+      <p:grpSpPr>
+        <a:xfrm>
+          <a:off x="0" y="0"/>
+          <a:ext cx="0" cy="0"/>
+          <a:chOff x="0" y="0"/>
+          <a:chExt cx="0" cy="0"/>
+        </a:xfrm>
+      </p:grpSpPr>
+      <p:sp>
+        <p:nvSpPr>
+          <p:cNvPr id="2" name="Slide Image Placeholder 1"/>
+          <p:cNvSpPr>
+            <a:spLocks noGrp="1"/>
+          </p:cNvSpPr>
+          <p:nvPr>
+            <p:ph type="sldImg" idx="2"/>
+          </p:nvPr>
+        </p:nvSpPr>
+        <p:spPr/>
+      </p:sp>
+      <p:sp>
+        <p:nvSpPr>
+          <p:cNvPr id="3" name="Notes Placeholder 2"/>
+          <p:cNvSpPr>
+            <a:spLocks noGrp="1"/>
+          </p:cNvSpPr>
+          <p:nvPr>
+            <p:ph type="body" idx="3" sz="quarter"/>
+          </p:nvPr>
+        </p:nvSpPr>
+        <p:spPr/>
+        <p:txBody>
+          <a:bodyPr/>
+          <a:lstStyle/>
+          <a:p>
+            <a:r>
+              <a:t>~45s. Walk the table: beats SPY on every row. The robustness card is the honest bit — beats equal weight only 3/5, so say 'close to equal weight, not a clear win.' Top contributors AAPL, XOM, KO.</a:t>
+            </a:r>
+          </a:p>
+        </p:txBody>
+      </p:sp>
+      <p:sp>
+        <p:nvSpPr>
+          <p:cNvPr id="4" name="Slide Number Placeholder 3"/>
+          <p:cNvSpPr>
+            <a:spLocks noGrp="1"/>
+          </p:cNvSpPr>
+          <p:nvPr>
+            <p:ph type="sldNum" idx="5" sz="quarter"/>
+          </p:nvPr>
+        </p:nvSpPr>
+        <p:spPr/>
+      </p:sp>
+    </p:spTree>
+  </p:cSld>
+  <p:clrMapOvr>
+    <a:masterClrMapping/>
+  </p:clrMapOvr>
+</p:notes>
+</file>
+
+<file path=ppt/notesSlides/notesSlide5.xml><?xml version="1.0" encoding="utf-8"?>
+<p:notes xmlns:a="http://schemas.openxmlformats.org/drawingml/2006/main" xmlns:p="http://schemas.openxmlformats.org/presentationml/2006/main" xmlns:r="http://schemas.openxmlformats.org/officeDocument/2006/relationships">
+  <p:cSld>
+    <p:spTree>
+      <p:nvGrpSpPr>
+        <p:cNvPr id="1" name=""/>
+        <p:cNvGrpSpPr/>
+        <p:nvPr/>
+      </p:nvGrpSpPr>
+      <p:grpSpPr>
+        <a:xfrm>
+          <a:off x="0" y="0"/>
+          <a:ext cx="0" cy="0"/>
+          <a:chOff x="0" y="0"/>
+          <a:chExt cx="0" cy="0"/>
+        </a:xfrm>
+      </p:grpSpPr>
+      <p:sp>
+        <p:nvSpPr>
+          <p:cNvPr id="2" name="Slide Image Placeholder 1"/>
+          <p:cNvSpPr>
+            <a:spLocks noGrp="1"/>
+          </p:cNvSpPr>
+          <p:nvPr>
+            <p:ph type="sldImg" idx="2"/>
+          </p:nvPr>
+        </p:nvSpPr>
+        <p:spPr/>
+      </p:sp>
+      <p:sp>
+        <p:nvSpPr>
+          <p:cNvPr id="3" name="Notes Placeholder 2"/>
+          <p:cNvSpPr>
+            <a:spLocks noGrp="1"/>
+          </p:cNvSpPr>
+          <p:nvPr>
+            <p:ph type="body" idx="3" sz="quarter"/>
+          </p:nvPr>
+        </p:nvSpPr>
+        <p:spPr/>
+        <p:txBody>
+          <a:bodyPr/>
+          <a:lstStyle/>
+          <a:p>
+            <a:r>
+              <a:t>~25s. Risk agent (report-only, 8/8 checks, learns across runs) and CrashLab (2008 -52%, 2020 -27%, proposes trims). Close on reproducibility, honest limits, the scorecard, and what's next. End on the disclaimer and questions.</a:t>
             </a:r>
           </a:p>
         </p:txBody>
@@ -3665,7 +3807,7 @@
             <a:avLst/>
           </a:prstGeom>
           <a:solidFill>
-            <a:srgbClr val="0B1522"/>
+            <a:srgbClr val="0A121F"/>
           </a:solidFill>
           <a:ln>
             <a:noFill/>
@@ -3702,14 +3844,14 @@
         </p:nvSpPr>
         <p:spPr>
           <a:xfrm>
-            <a:off x="640080" y="1078992"/>
-            <a:ext cx="2011680" cy="38100"/>
+            <a:off x="0" y="0"/>
+            <a:ext cx="109728" cy="6858000"/>
           </a:xfrm>
           <a:prstGeom prst="rect">
             <a:avLst/>
           </a:prstGeom>
           <a:solidFill>
-            <a:srgbClr val="F2C45A"/>
+            <a:srgbClr val="FF9900"/>
           </a:solidFill>
           <a:ln>
             <a:noFill/>
@@ -3740,105 +3882,23 @@
       </p:sp>
       <p:sp>
         <p:nvSpPr>
-          <p:cNvPr id="4" name="TextBox 3"/>
-          <p:cNvSpPr txBox="1"/>
+          <p:cNvPr id="4" name="Rectangle 3"/>
+          <p:cNvSpPr/>
           <p:nvPr/>
         </p:nvSpPr>
         <p:spPr>
           <a:xfrm>
-            <a:off x="640080" y="411480"/>
-            <a:ext cx="10972800" cy="822960"/>
+            <a:off x="109728" y="1874519"/>
+            <a:ext cx="12081967" cy="2514600"/>
           </a:xfrm>
           <a:prstGeom prst="rect">
             <a:avLst/>
           </a:prstGeom>
-          <a:noFill/>
-        </p:spPr>
-        <p:txBody>
-          <a:bodyPr wrap="square" anchor="t">
-            <a:spAutoFit/>
-          </a:bodyPr>
-          <a:lstStyle/>
-          <a:p>
-            <a:pPr algn="l">
-              <a:spcAft>
-                <a:spcPts val="400"/>
-              </a:spcAft>
-            </a:pPr>
-            <a:r>
-              <a:rPr sz="3600" b="1" i="0">
-                <a:solidFill>
-                  <a:srgbClr val="EAF1F8"/>
-                </a:solidFill>
-                <a:latin typeface="Segoe UI"/>
-              </a:rPr>
-              <a:t>Multi-agent portfolio research</a:t>
-            </a:r>
-          </a:p>
-        </p:txBody>
-      </p:sp>
-      <p:sp>
-        <p:nvSpPr>
-          <p:cNvPr id="5" name="TextBox 4"/>
-          <p:cNvSpPr txBox="1"/>
-          <p:nvPr/>
-        </p:nvSpPr>
-        <p:spPr>
-          <a:xfrm>
-            <a:off x="640080" y="1234440"/>
-            <a:ext cx="10881360" cy="822960"/>
-          </a:xfrm>
-          <a:prstGeom prst="rect">
-            <a:avLst/>
-          </a:prstGeom>
-          <a:noFill/>
-        </p:spPr>
-        <p:txBody>
-          <a:bodyPr wrap="square" anchor="t">
-            <a:spAutoFit/>
-          </a:bodyPr>
-          <a:lstStyle/>
-          <a:p>
-            <a:pPr algn="l">
-              <a:spcAft>
-                <a:spcPts val="400"/>
-              </a:spcAft>
-            </a:pPr>
-            <a:r>
-              <a:rPr sz="1600" b="0" i="0">
-                <a:solidFill>
-                  <a:srgbClr val="9FB0C0"/>
-                </a:solidFill>
-                <a:latin typeface="Segoe UI"/>
-              </a:rPr>
-              <a:t>Five analyst agents plus a portfolio manager build a portfolio from data up to a cutoff. A backtest scores it against what the market did next.</a:t>
-            </a:r>
-          </a:p>
-        </p:txBody>
-      </p:sp>
-      <p:sp>
-        <p:nvSpPr>
-          <p:cNvPr id="6" name="Rounded Rectangle 5"/>
-          <p:cNvSpPr/>
-          <p:nvPr/>
-        </p:nvSpPr>
-        <p:spPr>
-          <a:xfrm>
-            <a:off x="640080" y="2286000"/>
-            <a:ext cx="2615184" cy="1143000"/>
-          </a:xfrm>
-          <a:prstGeom prst="roundRect">
-            <a:avLst>
-              <a:gd name="adj" fmla="val 6000"/>
-            </a:avLst>
-          </a:prstGeom>
           <a:solidFill>
-            <a:srgbClr val="13263A"/>
+            <a:srgbClr val="0F1B2D"/>
           </a:solidFill>
-          <a:ln w="25400">
-            <a:solidFill>
-              <a:srgbClr val="1B5FA8"/>
-            </a:solidFill>
+          <a:ln>
+            <a:noFill/>
           </a:ln>
           <a:effectLst/>
         </p:spPr>
@@ -3866,14 +3926,14 @@
       </p:sp>
       <p:sp>
         <p:nvSpPr>
-          <p:cNvPr id="7" name="TextBox 6"/>
+          <p:cNvPr id="5" name="TextBox 4"/>
           <p:cNvSpPr txBox="1"/>
           <p:nvPr/>
         </p:nvSpPr>
         <p:spPr>
           <a:xfrm>
-            <a:off x="749808" y="2377440"/>
-            <a:ext cx="2395728" cy="960120"/>
+            <a:off x="502920" y="502920"/>
+            <a:ext cx="10972800" cy="457200"/>
           </a:xfrm>
           <a:prstGeom prst="rect">
             <a:avLst/>
@@ -3881,37 +3941,142 @@
           <a:noFill/>
         </p:spPr>
         <p:txBody>
-          <a:bodyPr wrap="square" anchor="ctr">
+          <a:bodyPr wrap="square" anchor="t">
             <a:spAutoFit/>
           </a:bodyPr>
           <a:lstStyle/>
           <a:p>
-            <a:pPr algn="ctr"/>
+            <a:pPr algn="l">
+              <a:spcAft>
+                <a:spcPts val="500"/>
+              </a:spcAft>
+            </a:pPr>
             <a:r>
               <a:rPr sz="1300" b="1" i="0">
                 <a:solidFill>
+                  <a:srgbClr val="FF9900"/>
+                </a:solidFill>
+                <a:latin typeface="Segoe UI"/>
+              </a:rPr>
+              <a:t>AGENTIC AI · FINANCIAL PORTFOLIO MANAGEMENT · TRACK 3</a:t>
+            </a:r>
+          </a:p>
+        </p:txBody>
+      </p:sp>
+      <p:sp>
+        <p:nvSpPr>
+          <p:cNvPr id="6" name="TextBox 5"/>
+          <p:cNvSpPr txBox="1"/>
+          <p:nvPr/>
+        </p:nvSpPr>
+        <p:spPr>
+          <a:xfrm>
+            <a:off x="685800" y="2103120"/>
+            <a:ext cx="10972800" cy="1280160"/>
+          </a:xfrm>
+          <a:prstGeom prst="rect">
+            <a:avLst/>
+          </a:prstGeom>
+          <a:noFill/>
+        </p:spPr>
+        <p:txBody>
+          <a:bodyPr wrap="square" anchor="t">
+            <a:spAutoFit/>
+          </a:bodyPr>
+          <a:lstStyle/>
+          <a:p>
+            <a:pPr algn="l">
+              <a:lnSpc>
+                <a:spcPct val="108000"/>
+              </a:lnSpc>
+              <a:spcAft>
+                <a:spcPts val="1000"/>
+              </a:spcAft>
+            </a:pPr>
+            <a:r>
+              <a:rPr sz="4000" b="1" i="0">
+                <a:solidFill>
                   <a:srgbClr val="EAF1F8"/>
                 </a:solidFill>
                 <a:latin typeface="Segoe UI"/>
               </a:rPr>
-              <a:t>Universe</a:t>
-            </a:r>
-          </a:p>
-          <a:p>
-            <a:pPr algn="ctr">
-              <a:spcBef>
-                <a:spcPts val="300"/>
-              </a:spcBef>
+              <a:t>Multi-agent portfolio research</a:t>
+            </a:r>
+          </a:p>
+          <a:p>
+            <a:pPr algn="l">
+              <a:lnSpc>
+                <a:spcPct val="108000"/>
+              </a:lnSpc>
+              <a:spcAft>
+                <a:spcPts val="1000"/>
+              </a:spcAft>
             </a:pPr>
             <a:r>
-              <a:rPr sz="950" b="0" i="0">
+              <a:rPr sz="1700" b="0" i="0">
                 <a:solidFill>
                   <a:srgbClr val="9FB0C0"/>
                 </a:solidFill>
                 <a:latin typeface="Segoe UI"/>
               </a:rPr>
-              <a:t>10 S&amp;P 500 names
-7+ sectors</a:t>
+              <a:t>Five specialist analyst agents and a portfolio manager build a defensible portfolio from point-in-time evidence, then a backtest scores it honestly against the market.</a:t>
+            </a:r>
+          </a:p>
+        </p:txBody>
+      </p:sp>
+      <p:sp>
+        <p:nvSpPr>
+          <p:cNvPr id="7" name="TextBox 6"/>
+          <p:cNvSpPr txBox="1"/>
+          <p:nvPr/>
+        </p:nvSpPr>
+        <p:spPr>
+          <a:xfrm>
+            <a:off x="685800" y="3886200"/>
+            <a:ext cx="10972800" cy="457200"/>
+          </a:xfrm>
+          <a:prstGeom prst="rect">
+            <a:avLst/>
+          </a:prstGeom>
+          <a:noFill/>
+        </p:spPr>
+        <p:txBody>
+          <a:bodyPr wrap="square" anchor="t">
+            <a:spAutoFit/>
+          </a:bodyPr>
+          <a:lstStyle/>
+          <a:p>
+            <a:pPr algn="l">
+              <a:spcAft>
+                <a:spcPts val="500"/>
+              </a:spcAft>
+            </a:pPr>
+            <a:r>
+              <a:rPr sz="1300" b="0" i="0">
+                <a:solidFill>
+                  <a:srgbClr val="9FB0C0"/>
+                </a:solidFill>
+                <a:latin typeface="Segoe UI"/>
+              </a:rPr>
+              <a:t>Built on AWS Bedrock (</a:t>
+            </a:r>
+            <a:r>
+              <a:rPr sz="1300" b="1" i="0">
+                <a:solidFill>
+                  <a:srgbClr val="FF9900"/>
+                </a:solidFill>
+                <a:latin typeface="Segoe UI"/>
+              </a:rPr>
+              <a:t>us.openai.gpt-5.6-luna</a:t>
+            </a:r>
+            <a:r>
+              <a:rPr sz="1300" b="0" i="0">
+                <a:solidFill>
+                  <a:srgbClr val="9FB0C0"/>
+                </a:solidFill>
+                <a:latin typeface="Segoe UI"/>
+              </a:rPr>
+              <a:t>, us-east-1) and Amazon Bedrock AgentCore.</a:t>
             </a:r>
           </a:p>
         </p:txBody>
@@ -3924,20 +4089,20 @@
         </p:nvSpPr>
         <p:spPr>
           <a:xfrm>
-            <a:off x="3465576" y="2286000"/>
-            <a:ext cx="2615184" cy="1143000"/>
+            <a:off x="685800" y="4800600"/>
+            <a:ext cx="2468880" cy="1005840"/>
           </a:xfrm>
           <a:prstGeom prst="roundRect">
             <a:avLst>
-              <a:gd name="adj" fmla="val 6000"/>
+              <a:gd name="adj" fmla="val 5000"/>
             </a:avLst>
           </a:prstGeom>
           <a:solidFill>
-            <a:srgbClr val="13263A"/>
+            <a:srgbClr val="142438"/>
           </a:solidFill>
-          <a:ln w="25400">
+          <a:ln w="19050">
             <a:solidFill>
-              <a:srgbClr val="9B3F7E"/>
+              <a:srgbClr val="EC7111"/>
             </a:solidFill>
           </a:ln>
           <a:effectLst/>
@@ -3972,8 +4137,8 @@
         </p:nvSpPr>
         <p:spPr>
           <a:xfrm>
-            <a:off x="3575304" y="2377440"/>
-            <a:ext cx="2395728" cy="960120"/>
+            <a:off x="868680" y="4937760"/>
+            <a:ext cx="2194560" cy="731520"/>
           </a:xfrm>
           <a:prstGeom prst="rect">
             <a:avLst/>
@@ -3981,36 +4146,40 @@
           <a:noFill/>
         </p:spPr>
         <p:txBody>
-          <a:bodyPr wrap="square" anchor="ctr">
+          <a:bodyPr wrap="square" anchor="t">
             <a:spAutoFit/>
           </a:bodyPr>
           <a:lstStyle/>
           <a:p>
-            <a:pPr algn="ctr"/>
-            <a:r>
-              <a:rPr sz="1300" b="1" i="0">
-                <a:solidFill>
-                  <a:srgbClr val="EAF1F8"/>
-                </a:solidFill>
-                <a:latin typeface="Segoe UI"/>
-              </a:rPr>
-              <a:t>Cutoff</a:t>
-            </a:r>
-          </a:p>
-          <a:p>
-            <a:pPr algn="ctr">
-              <a:spcBef>
-                <a:spcPts val="300"/>
-              </a:spcBef>
+            <a:pPr algn="l">
+              <a:spcAft>
+                <a:spcPts val="100"/>
+              </a:spcAft>
             </a:pPr>
             <a:r>
-              <a:rPr sz="950" b="0" i="0">
+              <a:rPr sz="2200" b="1" i="0">
+                <a:solidFill>
+                  <a:srgbClr val="FF9900"/>
+                </a:solidFill>
+                <a:latin typeface="Segoe UI"/>
+              </a:rPr>
+              <a:t>16.7%</a:t>
+            </a:r>
+          </a:p>
+          <a:p>
+            <a:pPr algn="l">
+              <a:spcAft>
+                <a:spcPts val="100"/>
+              </a:spcAft>
+            </a:pPr>
+            <a:r>
+              <a:rPr sz="1100" b="0" i="0">
                 <a:solidFill>
                   <a:srgbClr val="9FB0C0"/>
                 </a:solidFill>
                 <a:latin typeface="Segoe UI"/>
               </a:rPr>
-              <a:t>2026-01-30</a:t>
+              <a:t>Return</a:t>
             </a:r>
           </a:p>
         </p:txBody>
@@ -4023,20 +4192,20 @@
         </p:nvSpPr>
         <p:spPr>
           <a:xfrm>
-            <a:off x="6291072" y="2286000"/>
-            <a:ext cx="2615184" cy="1143000"/>
+            <a:off x="3383280" y="4800600"/>
+            <a:ext cx="2468880" cy="1005840"/>
           </a:xfrm>
           <a:prstGeom prst="roundRect">
             <a:avLst>
-              <a:gd name="adj" fmla="val 6000"/>
+              <a:gd name="adj" fmla="val 5000"/>
             </a:avLst>
           </a:prstGeom>
           <a:solidFill>
-            <a:srgbClr val="13263A"/>
+            <a:srgbClr val="142438"/>
           </a:solidFill>
-          <a:ln w="25400">
+          <a:ln w="19050">
             <a:solidFill>
-              <a:srgbClr val="0E7A5F"/>
+              <a:srgbClr val="EC7111"/>
             </a:solidFill>
           </a:ln>
           <a:effectLst/>
@@ -4071,8 +4240,8 @@
         </p:nvSpPr>
         <p:spPr>
           <a:xfrm>
-            <a:off x="6400800" y="2377440"/>
-            <a:ext cx="2395728" cy="960120"/>
+            <a:off x="3566160" y="4937760"/>
+            <a:ext cx="2194560" cy="731520"/>
           </a:xfrm>
           <a:prstGeom prst="rect">
             <a:avLst/>
@@ -4080,36 +4249,40 @@
           <a:noFill/>
         </p:spPr>
         <p:txBody>
-          <a:bodyPr wrap="square" anchor="ctr">
+          <a:bodyPr wrap="square" anchor="t">
             <a:spAutoFit/>
           </a:bodyPr>
           <a:lstStyle/>
           <a:p>
-            <a:pPr algn="ctr"/>
-            <a:r>
-              <a:rPr sz="1300" b="1" i="0">
-                <a:solidFill>
-                  <a:srgbClr val="EAF1F8"/>
-                </a:solidFill>
-                <a:latin typeface="Segoe UI"/>
-              </a:rPr>
-              <a:t>End scored</a:t>
-            </a:r>
-          </a:p>
-          <a:p>
-            <a:pPr algn="ctr">
-              <a:spcBef>
-                <a:spcPts val="300"/>
-              </a:spcBef>
+            <a:pPr algn="l">
+              <a:spcAft>
+                <a:spcPts val="100"/>
+              </a:spcAft>
             </a:pPr>
             <a:r>
-              <a:rPr sz="950" b="0" i="0">
+              <a:rPr sz="2200" b="1" i="0">
+                <a:solidFill>
+                  <a:srgbClr val="FF9900"/>
+                </a:solidFill>
+                <a:latin typeface="Segoe UI"/>
+              </a:rPr>
+              <a:t>2.37</a:t>
+            </a:r>
+          </a:p>
+          <a:p>
+            <a:pPr algn="l">
+              <a:spcAft>
+                <a:spcPts val="100"/>
+              </a:spcAft>
+            </a:pPr>
+            <a:r>
+              <a:rPr sz="1100" b="0" i="0">
                 <a:solidFill>
                   <a:srgbClr val="9FB0C0"/>
                 </a:solidFill>
                 <a:latin typeface="Segoe UI"/>
               </a:rPr>
-              <a:t>2026-10-16</a:t>
+              <a:t>Sharpe</a:t>
             </a:r>
           </a:p>
         </p:txBody>
@@ -4122,20 +4295,20 @@
         </p:nvSpPr>
         <p:spPr>
           <a:xfrm>
-            <a:off x="9116567" y="2286000"/>
-            <a:ext cx="2615184" cy="1143000"/>
+            <a:off x="6080760" y="4800600"/>
+            <a:ext cx="2468880" cy="1005840"/>
           </a:xfrm>
           <a:prstGeom prst="roundRect">
             <a:avLst>
-              <a:gd name="adj" fmla="val 6000"/>
+              <a:gd name="adj" fmla="val 5000"/>
             </a:avLst>
           </a:prstGeom>
           <a:solidFill>
-            <a:srgbClr val="13263A"/>
+            <a:srgbClr val="142438"/>
           </a:solidFill>
-          <a:ln w="25400">
+          <a:ln w="19050">
             <a:solidFill>
-              <a:srgbClr val="1B5FA8"/>
+              <a:srgbClr val="EC7111"/>
             </a:solidFill>
           </a:ln>
           <a:effectLst/>
@@ -4170,8 +4343,8 @@
         </p:nvSpPr>
         <p:spPr>
           <a:xfrm>
-            <a:off x="9226295" y="2377440"/>
-            <a:ext cx="2395728" cy="960120"/>
+            <a:off x="6263640" y="4937760"/>
+            <a:ext cx="2194560" cy="731520"/>
           </a:xfrm>
           <a:prstGeom prst="rect">
             <a:avLst/>
@@ -4179,36 +4352,40 @@
           <a:noFill/>
         </p:spPr>
         <p:txBody>
-          <a:bodyPr wrap="square" anchor="ctr">
+          <a:bodyPr wrap="square" anchor="t">
             <a:spAutoFit/>
           </a:bodyPr>
           <a:lstStyle/>
           <a:p>
-            <a:pPr algn="ctr"/>
-            <a:r>
-              <a:rPr sz="1300" b="1" i="0">
-                <a:solidFill>
-                  <a:srgbClr val="EAF1F8"/>
-                </a:solidFill>
-                <a:latin typeface="Segoe UI"/>
-              </a:rPr>
-              <a:t>Baselines</a:t>
-            </a:r>
-          </a:p>
-          <a:p>
-            <a:pPr algn="ctr">
-              <a:spcBef>
-                <a:spcPts val="300"/>
-              </a:spcBef>
+            <a:pPr algn="l">
+              <a:spcAft>
+                <a:spcPts val="100"/>
+              </a:spcAft>
             </a:pPr>
             <a:r>
-              <a:rPr sz="950" b="0" i="0">
+              <a:rPr sz="2200" b="1" i="0">
+                <a:solidFill>
+                  <a:srgbClr val="FF9900"/>
+                </a:solidFill>
+                <a:latin typeface="Segoe UI"/>
+              </a:rPr>
+              <a:t>-5.3%</a:t>
+            </a:r>
+          </a:p>
+          <a:p>
+            <a:pPr algn="l">
+              <a:spcAft>
+                <a:spcPts val="100"/>
+              </a:spcAft>
+            </a:pPr>
+            <a:r>
+              <a:rPr sz="1100" b="0" i="0">
                 <a:solidFill>
                   <a:srgbClr val="9FB0C0"/>
                 </a:solidFill>
                 <a:latin typeface="Segoe UI"/>
               </a:rPr>
-              <a:t>SPY, equal weight</a:t>
+              <a:t>Max drawdown</a:t>
             </a:r>
           </a:p>
         </p:txBody>
@@ -4221,20 +4398,20 @@
         </p:nvSpPr>
         <p:spPr>
           <a:xfrm>
-            <a:off x="640080" y="3749039"/>
-            <a:ext cx="10908792" cy="914400"/>
+            <a:off x="8778240" y="4800600"/>
+            <a:ext cx="2468880" cy="1005840"/>
           </a:xfrm>
           <a:prstGeom prst="roundRect">
             <a:avLst>
-              <a:gd name="adj" fmla="val 6000"/>
+              <a:gd name="adj" fmla="val 5000"/>
             </a:avLst>
           </a:prstGeom>
           <a:solidFill>
-            <a:srgbClr val="1A2412"/>
+            <a:srgbClr val="142438"/>
           </a:solidFill>
-          <a:ln w="15875">
+          <a:ln w="19050">
             <a:solidFill>
-              <a:srgbClr val="5A6D1F"/>
+              <a:srgbClr val="EC7111"/>
             </a:solidFill>
           </a:ln>
           <a:effectLst/>
@@ -4269,8 +4446,8 @@
         </p:nvSpPr>
         <p:spPr>
           <a:xfrm>
-            <a:off x="868680" y="3913632"/>
-            <a:ext cx="10515600" cy="640080"/>
+            <a:off x="8961120" y="4937760"/>
+            <a:ext cx="2194560" cy="731520"/>
           </a:xfrm>
           <a:prstGeom prst="rect">
             <a:avLst/>
@@ -4278,33 +4455,40 @@
           <a:noFill/>
         </p:spPr>
         <p:txBody>
-          <a:bodyPr wrap="square" anchor="ctr">
+          <a:bodyPr wrap="square" anchor="t">
             <a:spAutoFit/>
           </a:bodyPr>
           <a:lstStyle/>
           <a:p>
             <a:pPr algn="l">
               <a:spcAft>
-                <a:spcPts val="400"/>
+                <a:spcPts val="100"/>
               </a:spcAft>
             </a:pPr>
             <a:r>
-              <a:rPr sz="1500" b="1" i="0">
-                <a:solidFill>
-                  <a:srgbClr val="F2C45A"/>
-                </a:solidFill>
-                <a:latin typeface="Segoe UI"/>
-              </a:rPr>
-              <a:t>No peeking.  </a:t>
-            </a:r>
-            <a:r>
-              <a:rPr sz="1350" b="0" i="0">
-                <a:solidFill>
-                  <a:srgbClr val="EAF1F8"/>
-                </a:solidFill>
-                <a:latin typeface="Segoe UI"/>
-              </a:rPr>
-              <a:t>One point-in-time guard is the only door to data, and a leakage test fails the run if any date slips past the cutoff.</a:t>
+              <a:rPr sz="2200" b="1" i="0">
+                <a:solidFill>
+                  <a:srgbClr val="FF9900"/>
+                </a:solidFill>
+                <a:latin typeface="Segoe UI"/>
+              </a:rPr>
+              <a:t>5 / 5 runs</a:t>
+            </a:r>
+          </a:p>
+          <a:p>
+            <a:pPr algn="l">
+              <a:spcAft>
+                <a:spcPts val="100"/>
+              </a:spcAft>
+            </a:pPr>
+            <a:r>
+              <a:rPr sz="1100" b="0" i="0">
+                <a:solidFill>
+                  <a:srgbClr val="9FB0C0"/>
+                </a:solidFill>
+                <a:latin typeface="Segoe UI"/>
+              </a:rPr>
+              <a:t>Beats SPY</a:t>
             </a:r>
           </a:p>
         </p:txBody>
@@ -4317,8 +4501,8 @@
         </p:nvSpPr>
         <p:spPr>
           <a:xfrm>
-            <a:off x="640080" y="4892040"/>
-            <a:ext cx="10881360" cy="457200"/>
+            <a:off x="502920" y="6446520"/>
+            <a:ext cx="9144000" cy="274320"/>
           </a:xfrm>
           <a:prstGeom prst="rect">
             <a:avLst/>
@@ -4333,17 +4517,56 @@
           <a:p>
             <a:pPr algn="l">
               <a:spcAft>
-                <a:spcPts val="400"/>
+                <a:spcPts val="500"/>
               </a:spcAft>
             </a:pPr>
             <a:r>
-              <a:rPr sz="1200" b="0" i="1">
+              <a:rPr sz="800" b="0" i="0">
+                <a:solidFill>
+                  <a:srgbClr val="5A6D80"/>
+                </a:solidFill>
+                <a:latin typeface="Segoe UI"/>
+              </a:rPr>
+              <a:t>Multi-agent portfolio research · Austin Agentic AI Hackathon · historical experiment, not financial advice</a:t>
+            </a:r>
+          </a:p>
+        </p:txBody>
+      </p:sp>
+      <p:sp>
+        <p:nvSpPr>
+          <p:cNvPr id="17" name="TextBox 16"/>
+          <p:cNvSpPr txBox="1"/>
+          <p:nvPr/>
+        </p:nvSpPr>
+        <p:spPr>
+          <a:xfrm>
+            <a:off x="11338560" y="6446520"/>
+            <a:ext cx="548640" cy="274320"/>
+          </a:xfrm>
+          <a:prstGeom prst="rect">
+            <a:avLst/>
+          </a:prstGeom>
+          <a:noFill/>
+        </p:spPr>
+        <p:txBody>
+          <a:bodyPr wrap="square" anchor="t">
+            <a:spAutoFit/>
+          </a:bodyPr>
+          <a:lstStyle/>
+          <a:p>
+            <a:pPr algn="r">
+              <a:spcAft>
+                <a:spcPts val="500"/>
+              </a:spcAft>
+            </a:pPr>
+            <a:r>
+              <a:rPr sz="900" b="0" i="0">
                 <a:solidFill>
                   <a:srgbClr val="9FB0C0"/>
                 </a:solidFill>
                 <a:latin typeface="Segoe UI"/>
               </a:rPr>
-              <a:t>Historical experiment, not financial advice or a trading recommendation.</a:t>
+              <a:t>1</a:t>
             </a:r>
           </a:p>
         </p:txBody>
@@ -4381,7 +4604,7 @@
             <a:avLst/>
           </a:prstGeom>
           <a:solidFill>
-            <a:srgbClr val="0B1522"/>
+            <a:srgbClr val="0A121F"/>
           </a:solidFill>
           <a:ln>
             <a:noFill/>
@@ -4418,14 +4641,14 @@
         </p:nvSpPr>
         <p:spPr>
           <a:xfrm>
-            <a:off x="640080" y="1078992"/>
-            <a:ext cx="2011680" cy="38100"/>
+            <a:off x="0" y="0"/>
+            <a:ext cx="109728" cy="6858000"/>
           </a:xfrm>
           <a:prstGeom prst="rect">
             <a:avLst/>
           </a:prstGeom>
           <a:solidFill>
-            <a:srgbClr val="F2C45A"/>
+            <a:srgbClr val="FF9900"/>
           </a:solidFill>
           <a:ln>
             <a:noFill/>
@@ -4462,8 +4685,8 @@
         </p:nvSpPr>
         <p:spPr>
           <a:xfrm>
-            <a:off x="640080" y="411480"/>
-            <a:ext cx="10972800" cy="640080"/>
+            <a:off x="502920" y="274320"/>
+            <a:ext cx="10058400" cy="365760"/>
           </a:xfrm>
           <a:prstGeom prst="rect">
             <a:avLst/>
@@ -4478,43 +4701,82 @@
           <a:p>
             <a:pPr algn="l">
               <a:spcAft>
-                <a:spcPts val="400"/>
+                <a:spcPts val="500"/>
               </a:spcAft>
             </a:pPr>
             <a:r>
-              <a:rPr sz="3000" b="1" i="0">
+              <a:rPr sz="1200" b="1" i="0">
+                <a:solidFill>
+                  <a:srgbClr val="FF9900"/>
+                </a:solidFill>
+                <a:latin typeface="Segoe UI"/>
+              </a:rPr>
+              <a:t>ARCHITECTURE</a:t>
+            </a:r>
+          </a:p>
+        </p:txBody>
+      </p:sp>
+      <p:sp>
+        <p:nvSpPr>
+          <p:cNvPr id="5" name="TextBox 4"/>
+          <p:cNvSpPr txBox="1"/>
+          <p:nvPr/>
+        </p:nvSpPr>
+        <p:spPr>
+          <a:xfrm>
+            <a:off x="502920" y="658368"/>
+            <a:ext cx="11155680" cy="731520"/>
+          </a:xfrm>
+          <a:prstGeom prst="rect">
+            <a:avLst/>
+          </a:prstGeom>
+          <a:noFill/>
+        </p:spPr>
+        <p:txBody>
+          <a:bodyPr wrap="square" anchor="t">
+            <a:spAutoFit/>
+          </a:bodyPr>
+          <a:lstStyle/>
+          <a:p>
+            <a:pPr algn="l">
+              <a:spcAft>
+                <a:spcPts val="500"/>
+              </a:spcAft>
+            </a:pPr>
+            <a:r>
+              <a:rPr sz="2900" b="1" i="0">
                 <a:solidFill>
                   <a:srgbClr val="EAF1F8"/>
                 </a:solidFill>
                 <a:latin typeface="Segoe UI"/>
               </a:rPr>
-              <a:t>How it thinks</a:t>
-            </a:r>
-          </a:p>
-        </p:txBody>
-      </p:sp>
-      <p:sp>
-        <p:nvSpPr>
-          <p:cNvPr id="5" name="Rounded Rectangle 4"/>
+              <a:t>How it thinks: evidence in, a decision it can defend</a:t>
+            </a:r>
+          </a:p>
+        </p:txBody>
+      </p:sp>
+      <p:sp>
+        <p:nvSpPr>
+          <p:cNvPr id="6" name="Rounded Rectangle 5"/>
           <p:cNvSpPr/>
           <p:nvPr/>
         </p:nvSpPr>
         <p:spPr>
           <a:xfrm>
-            <a:off x="640080" y="1280160"/>
-            <a:ext cx="2505456" cy="1371600"/>
+            <a:off x="640080" y="1371600"/>
+            <a:ext cx="2505456" cy="1280160"/>
           </a:xfrm>
           <a:prstGeom prst="roundRect">
             <a:avLst>
-              <a:gd name="adj" fmla="val 6000"/>
+              <a:gd name="adj" fmla="val 5000"/>
             </a:avLst>
           </a:prstGeom>
           <a:solidFill>
-            <a:srgbClr val="13263A"/>
+            <a:srgbClr val="142438"/>
           </a:solidFill>
           <a:ln w="25400">
             <a:solidFill>
-              <a:srgbClr val="0E7A5F"/>
+              <a:srgbClr val="1C8A5E"/>
             </a:solidFill>
           </a:ln>
           <a:effectLst/>
@@ -4543,14 +4805,14 @@
       </p:sp>
       <p:sp>
         <p:nvSpPr>
-          <p:cNvPr id="6" name="TextBox 5"/>
+          <p:cNvPr id="7" name="TextBox 6"/>
           <p:cNvSpPr txBox="1"/>
           <p:nvPr/>
         </p:nvSpPr>
         <p:spPr>
           <a:xfrm>
-            <a:off x="749808" y="1371600"/>
-            <a:ext cx="2286000" cy="1188720"/>
+            <a:off x="749808" y="1444752"/>
+            <a:ext cx="2286000" cy="1133856"/>
           </a:xfrm>
           <a:prstGeom prst="rect">
             <a:avLst/>
@@ -4565,51 +4827,51 @@
           <a:p>
             <a:pPr algn="ctr"/>
             <a:r>
-              <a:rPr sz="1300" b="1" i="0">
+              <a:rPr sz="1200" b="1" i="0">
                 <a:solidFill>
                   <a:srgbClr val="EAF1F8"/>
                 </a:solidFill>
                 <a:latin typeface="Segoe UI"/>
               </a:rPr>
-              <a:t>Evidence</a:t>
+              <a:t>Evidence packs</a:t>
             </a:r>
           </a:p>
           <a:p>
             <a:pPr algn="ctr">
               <a:spcBef>
-                <a:spcPts val="300"/>
+                <a:spcPts val="200"/>
               </a:spcBef>
             </a:pPr>
             <a:r>
-              <a:rPr sz="950" b="0" i="0">
+              <a:rPr sz="850" b="0" i="0">
                 <a:solidFill>
                   <a:srgbClr val="9FB0C0"/>
                 </a:solidFill>
                 <a:latin typeface="Segoe UI"/>
               </a:rPr>
-              <a:t>prices · macro · filings
-news · geopolitics
-(each claim cites an ID)</a:t>
-            </a:r>
-          </a:p>
-        </p:txBody>
-      </p:sp>
-      <p:sp>
-        <p:nvSpPr>
-          <p:cNvPr id="7" name="Right Arrow 6"/>
+              <a:t>prices, macro, SEC
+filings, news, geo
+each item an ID</a:t>
+            </a:r>
+          </a:p>
+        </p:txBody>
+      </p:sp>
+      <p:sp>
+        <p:nvSpPr>
+          <p:cNvPr id="8" name="Right Arrow 7"/>
           <p:cNvSpPr/>
           <p:nvPr/>
         </p:nvSpPr>
         <p:spPr>
           <a:xfrm>
-            <a:off x="3163824" y="1828800"/>
-            <a:ext cx="320040" cy="274320"/>
+            <a:off x="3163824" y="1901952"/>
+            <a:ext cx="256032" cy="219456"/>
           </a:xfrm>
           <a:prstGeom prst="rightArrow">
             <a:avLst/>
           </a:prstGeom>
           <a:solidFill>
-            <a:srgbClr val="7FA6CC"/>
+            <a:srgbClr val="FF9900"/>
           </a:solidFill>
           <a:ln>
             <a:noFill/>
@@ -4640,22 +4902,22 @@
       </p:sp>
       <p:sp>
         <p:nvSpPr>
-          <p:cNvPr id="8" name="Rounded Rectangle 7"/>
+          <p:cNvPr id="9" name="Rounded Rectangle 8"/>
           <p:cNvSpPr/>
           <p:nvPr/>
         </p:nvSpPr>
         <p:spPr>
           <a:xfrm>
-            <a:off x="3502152" y="1280160"/>
-            <a:ext cx="2505456" cy="1371600"/>
+            <a:off x="3502152" y="1371600"/>
+            <a:ext cx="2505456" cy="1280160"/>
           </a:xfrm>
           <a:prstGeom prst="roundRect">
             <a:avLst>
-              <a:gd name="adj" fmla="val 6000"/>
+              <a:gd name="adj" fmla="val 5000"/>
             </a:avLst>
           </a:prstGeom>
           <a:solidFill>
-            <a:srgbClr val="13263A"/>
+            <a:srgbClr val="142438"/>
           </a:solidFill>
           <a:ln w="25400">
             <a:solidFill>
@@ -4688,14 +4950,14 @@
       </p:sp>
       <p:sp>
         <p:nvSpPr>
-          <p:cNvPr id="9" name="TextBox 8"/>
+          <p:cNvPr id="10" name="TextBox 9"/>
           <p:cNvSpPr txBox="1"/>
           <p:nvPr/>
         </p:nvSpPr>
         <p:spPr>
           <a:xfrm>
-            <a:off x="3611880" y="1371600"/>
-            <a:ext cx="2286000" cy="1188720"/>
+            <a:off x="3611880" y="1444752"/>
+            <a:ext cx="2286000" cy="1133856"/>
           </a:xfrm>
           <a:prstGeom prst="rect">
             <a:avLst/>
@@ -4710,7 +4972,7 @@
           <a:p>
             <a:pPr algn="ctr"/>
             <a:r>
-              <a:rPr sz="1300" b="1" i="0">
+              <a:rPr sz="1200" b="1" i="0">
                 <a:solidFill>
                   <a:srgbClr val="EAF1F8"/>
                 </a:solidFill>
@@ -4722,39 +4984,39 @@
           <a:p>
             <a:pPr algn="ctr">
               <a:spcBef>
-                <a:spcPts val="300"/>
+                <a:spcPts val="200"/>
               </a:spcBef>
             </a:pPr>
             <a:r>
-              <a:rPr sz="950" b="0" i="0">
+              <a:rPr sz="850" b="0" i="0">
                 <a:solidFill>
                   <a:srgbClr val="9FB0C0"/>
                 </a:solidFill>
                 <a:latin typeface="Segoe UI"/>
               </a:rPr>
-              <a:t>technical · fundamentals
-macro · sentiment · geopolitics
-stance + confidence</a:t>
-            </a:r>
-          </a:p>
-        </p:txBody>
-      </p:sp>
-      <p:sp>
-        <p:nvSpPr>
-          <p:cNvPr id="10" name="Right Arrow 9"/>
+              <a:t>technical, fundamentals
+macro, sentiment
+geopolitics</a:t>
+            </a:r>
+          </a:p>
+        </p:txBody>
+      </p:sp>
+      <p:sp>
+        <p:nvSpPr>
+          <p:cNvPr id="11" name="Right Arrow 10"/>
           <p:cNvSpPr/>
           <p:nvPr/>
         </p:nvSpPr>
         <p:spPr>
           <a:xfrm>
-            <a:off x="6025896" y="1828800"/>
-            <a:ext cx="320040" cy="274320"/>
+            <a:off x="6025896" y="1901952"/>
+            <a:ext cx="256032" cy="219456"/>
           </a:xfrm>
           <a:prstGeom prst="rightArrow">
             <a:avLst/>
           </a:prstGeom>
           <a:solidFill>
-            <a:srgbClr val="7FA6CC"/>
+            <a:srgbClr val="FF9900"/>
           </a:solidFill>
           <a:ln>
             <a:noFill/>
@@ -4785,22 +5047,22 @@
       </p:sp>
       <p:sp>
         <p:nvSpPr>
-          <p:cNvPr id="11" name="Rounded Rectangle 10"/>
+          <p:cNvPr id="12" name="Rounded Rectangle 11"/>
           <p:cNvSpPr/>
           <p:nvPr/>
         </p:nvSpPr>
         <p:spPr>
           <a:xfrm>
-            <a:off x="6364224" y="1280160"/>
-            <a:ext cx="2505456" cy="1371600"/>
+            <a:off x="6364224" y="1371600"/>
+            <a:ext cx="2505456" cy="1280160"/>
           </a:xfrm>
           <a:prstGeom prst="roundRect">
             <a:avLst>
-              <a:gd name="adj" fmla="val 6000"/>
+              <a:gd name="adj" fmla="val 5000"/>
             </a:avLst>
           </a:prstGeom>
           <a:solidFill>
-            <a:srgbClr val="13263A"/>
+            <a:srgbClr val="142438"/>
           </a:solidFill>
           <a:ln w="25400">
             <a:solidFill>
@@ -4833,14 +5095,14 @@
       </p:sp>
       <p:sp>
         <p:nvSpPr>
-          <p:cNvPr id="12" name="TextBox 11"/>
+          <p:cNvPr id="13" name="TextBox 12"/>
           <p:cNvSpPr txBox="1"/>
           <p:nvPr/>
         </p:nvSpPr>
         <p:spPr>
           <a:xfrm>
-            <a:off x="6473952" y="1371600"/>
-            <a:ext cx="2286000" cy="1188720"/>
+            <a:off x="6473952" y="1444752"/>
+            <a:ext cx="2286000" cy="1133856"/>
           </a:xfrm>
           <a:prstGeom prst="rect">
             <a:avLst/>
@@ -4855,7 +5117,7 @@
           <a:p>
             <a:pPr algn="ctr"/>
             <a:r>
-              <a:rPr sz="1300" b="1" i="0">
+              <a:rPr sz="1200" b="1" i="0">
                 <a:solidFill>
                   <a:srgbClr val="EAF1F8"/>
                 </a:solidFill>
@@ -4867,18 +5129,18 @@
           <a:p>
             <a:pPr algn="ctr">
               <a:spcBef>
-                <a:spcPts val="300"/>
+                <a:spcPts val="200"/>
               </a:spcBef>
             </a:pPr>
             <a:r>
-              <a:rPr sz="950" b="0" i="0">
+              <a:rPr sz="850" b="0" i="0">
                 <a:solidFill>
                   <a:srgbClr val="9FB0C0"/>
                 </a:solidFill>
                 <a:latin typeface="Segoe UI"/>
               </a:rPr>
-              <a:t>reconciles conflicts into
-weights, rationale,
+              <a:t>reconciles conflicts
+-&gt; weights, rationale,
 sources, triggers</a:t>
             </a:r>
           </a:p>
@@ -4886,20 +5148,20 @@
       </p:sp>
       <p:sp>
         <p:nvSpPr>
-          <p:cNvPr id="13" name="Right Arrow 12"/>
+          <p:cNvPr id="14" name="Right Arrow 13"/>
           <p:cNvSpPr/>
           <p:nvPr/>
         </p:nvSpPr>
         <p:spPr>
           <a:xfrm>
-            <a:off x="8887968" y="1828800"/>
-            <a:ext cx="320040" cy="274320"/>
+            <a:off x="8887968" y="1901952"/>
+            <a:ext cx="256032" cy="219456"/>
           </a:xfrm>
           <a:prstGeom prst="rightArrow">
             <a:avLst/>
           </a:prstGeom>
           <a:solidFill>
-            <a:srgbClr val="7FA6CC"/>
+            <a:srgbClr val="FF9900"/>
           </a:solidFill>
           <a:ln>
             <a:noFill/>
@@ -4930,22 +5192,22 @@
       </p:sp>
       <p:sp>
         <p:nvSpPr>
-          <p:cNvPr id="14" name="Rounded Rectangle 13"/>
+          <p:cNvPr id="15" name="Rounded Rectangle 14"/>
           <p:cNvSpPr/>
           <p:nvPr/>
         </p:nvSpPr>
         <p:spPr>
           <a:xfrm>
-            <a:off x="9226296" y="1280160"/>
-            <a:ext cx="2505456" cy="1371600"/>
+            <a:off x="9226296" y="1371600"/>
+            <a:ext cx="2505456" cy="1280160"/>
           </a:xfrm>
           <a:prstGeom prst="roundRect">
             <a:avLst>
-              <a:gd name="adj" fmla="val 6000"/>
+              <a:gd name="adj" fmla="val 5000"/>
             </a:avLst>
           </a:prstGeom>
           <a:solidFill>
-            <a:srgbClr val="13263A"/>
+            <a:srgbClr val="142438"/>
           </a:solidFill>
           <a:ln w="25400">
             <a:solidFill>
@@ -4978,14 +5240,14 @@
       </p:sp>
       <p:sp>
         <p:nvSpPr>
-          <p:cNvPr id="15" name="TextBox 14"/>
+          <p:cNvPr id="16" name="TextBox 15"/>
           <p:cNvSpPr txBox="1"/>
           <p:nvPr/>
         </p:nvSpPr>
         <p:spPr>
           <a:xfrm>
-            <a:off x="9336024" y="1371600"/>
-            <a:ext cx="2286000" cy="1188720"/>
+            <a:off x="9336024" y="1444752"/>
+            <a:ext cx="2286000" cy="1133856"/>
           </a:xfrm>
           <a:prstGeom prst="rect">
             <a:avLst/>
@@ -5000,7 +5262,7 @@
           <a:p>
             <a:pPr algn="ctr"/>
             <a:r>
-              <a:rPr sz="1300" b="1" i="0">
+              <a:rPr sz="1200" b="1" i="0">
                 <a:solidFill>
                   <a:srgbClr val="EAF1F8"/>
                 </a:solidFill>
@@ -5012,32 +5274,33 @@
           <a:p>
             <a:pPr algn="ctr">
               <a:spcBef>
-                <a:spcPts val="300"/>
+                <a:spcPts val="200"/>
               </a:spcBef>
             </a:pPr>
             <a:r>
-              <a:rPr sz="950" b="0" i="0">
+              <a:rPr sz="850" b="0" i="0">
                 <a:solidFill>
                   <a:srgbClr val="9FB0C0"/>
                 </a:solidFill>
                 <a:latin typeface="Segoe UI"/>
               </a:rPr>
               <a:t>vs SPY &amp; equal weight
-fees, metrics</a:t>
-            </a:r>
-          </a:p>
-        </p:txBody>
-      </p:sp>
-      <p:sp>
-        <p:nvSpPr>
-          <p:cNvPr id="16" name="TextBox 15"/>
+fees, Sharpe,
+drawdown</a:t>
+            </a:r>
+          </a:p>
+        </p:txBody>
+      </p:sp>
+      <p:sp>
+        <p:nvSpPr>
+          <p:cNvPr id="17" name="TextBox 16"/>
           <p:cNvSpPr txBox="1"/>
           <p:nvPr/>
         </p:nvSpPr>
         <p:spPr>
           <a:xfrm>
-            <a:off x="640080" y="2926080"/>
-            <a:ext cx="10972800" cy="548640"/>
+            <a:off x="640080" y="2834640"/>
+            <a:ext cx="11064240" cy="548640"/>
           </a:xfrm>
           <a:prstGeom prst="rect">
             <a:avLst/>
@@ -5051,53 +5314,56 @@
           <a:lstStyle/>
           <a:p>
             <a:pPr algn="l">
+              <a:lnSpc>
+                <a:spcPct val="110000"/>
+              </a:lnSpc>
               <a:spcAft>
-                <a:spcPts val="400"/>
+                <a:spcPts val="500"/>
               </a:spcAft>
             </a:pPr>
             <a:r>
-              <a:rPr sz="2200" b="1" i="0">
-                <a:solidFill>
-                  <a:srgbClr val="EAF1F8"/>
-                </a:solidFill>
-                <a:latin typeface="Segoe UI"/>
-              </a:rPr>
-              <a:t>Open one decision </a:t>
-            </a:r>
-            <a:r>
-              <a:rPr sz="1500" b="1" i="0">
-                <a:solidFill>
-                  <a:srgbClr val="F2C45A"/>
-                </a:solidFill>
-                <a:latin typeface="Segoe UI"/>
-              </a:rPr>
-              <a:t>— the biggest analyst disagreement</a:t>
-            </a:r>
-          </a:p>
-        </p:txBody>
-      </p:sp>
-      <p:sp>
-        <p:nvSpPr>
-          <p:cNvPr id="17" name="Rounded Rectangle 16"/>
+              <a:rPr sz="1400" b="1" i="0">
+                <a:solidFill>
+                  <a:srgbClr val="FF9900"/>
+                </a:solidFill>
+                <a:latin typeface="Segoe UI"/>
+              </a:rPr>
+              <a:t>The cutoff is a one-way valve. </a:t>
+            </a:r>
+            <a:r>
+              <a:rPr sz="1400" b="0" i="0">
+                <a:solidFill>
+                  <a:srgbClr val="9FB0C0"/>
+                </a:solidFill>
+                <a:latin typeface="Segoe UI"/>
+              </a:rPr>
+              <a:t>Agents read only evidence built through a point-in-time guard; the single file that crosses into the future is decision.json, frozen before any later price is loaded.</a:t>
+            </a:r>
+          </a:p>
+        </p:txBody>
+      </p:sp>
+      <p:sp>
+        <p:nvSpPr>
+          <p:cNvPr id="18" name="Rounded Rectangle 17"/>
           <p:cNvSpPr/>
           <p:nvPr/>
         </p:nvSpPr>
         <p:spPr>
           <a:xfrm>
             <a:off x="640080" y="3611880"/>
-            <a:ext cx="5394960" cy="2377440"/>
+            <a:ext cx="3529584" cy="2286000"/>
           </a:xfrm>
           <a:prstGeom prst="roundRect">
             <a:avLst>
-              <a:gd name="adj" fmla="val 6000"/>
+              <a:gd name="adj" fmla="val 5000"/>
             </a:avLst>
           </a:prstGeom>
           <a:solidFill>
-            <a:srgbClr val="13263A"/>
+            <a:srgbClr val="142438"/>
           </a:solidFill>
           <a:ln w="25400">
             <a:solidFill>
-              <a:srgbClr val="9B3F7E"/>
+              <a:srgbClr val="1C8A5E"/>
             </a:solidFill>
           </a:ln>
           <a:effectLst/>
@@ -5126,14 +5392,14 @@
       </p:sp>
       <p:sp>
         <p:nvSpPr>
-          <p:cNvPr id="18" name="TextBox 17"/>
+          <p:cNvPr id="19" name="TextBox 18"/>
           <p:cNvSpPr txBox="1"/>
           <p:nvPr/>
         </p:nvSpPr>
         <p:spPr>
           <a:xfrm>
-            <a:off x="868680" y="3794760"/>
-            <a:ext cx="4937760" cy="2103120"/>
+            <a:off x="822959" y="3730752"/>
+            <a:ext cx="3163824" cy="2103120"/>
           </a:xfrm>
           <a:prstGeom prst="rect">
             <a:avLst/>
@@ -5147,151 +5413,62 @@
           <a:lstStyle/>
           <a:p>
             <a:pPr algn="l">
+              <a:lnSpc>
+                <a:spcPct val="108000"/>
+              </a:lnSpc>
               <a:spcAft>
-                <a:spcPts val="800"/>
+                <a:spcPts val="600"/>
               </a:spcAft>
             </a:pPr>
             <a:r>
-              <a:rPr sz="1600" b="1" i="0">
-                <a:solidFill>
-                  <a:srgbClr val="F2C45A"/>
-                </a:solidFill>
-                <a:latin typeface="Segoe UI"/>
-              </a:rPr>
-              <a:t>MSFT</a:t>
-            </a:r>
-            <a:r>
-              <a:rPr sz="1200" b="0" i="0">
-                <a:solidFill>
-                  <a:srgbClr val="9FB0C0"/>
-                </a:solidFill>
-                <a:latin typeface="Segoe UI"/>
-              </a:rPr>
-              <a:t>  most contested (spread 0.78)</a:t>
+              <a:rPr sz="1450" b="1" i="0">
+                <a:solidFill>
+                  <a:srgbClr val="EAF1F8"/>
+                </a:solidFill>
+                <a:latin typeface="Segoe UI"/>
+              </a:rPr>
+              <a:t>No peeking</a:t>
             </a:r>
           </a:p>
           <a:p>
             <a:pPr algn="l">
+              <a:lnSpc>
+                <a:spcPct val="108000"/>
+              </a:lnSpc>
               <a:spcAft>
-                <a:spcPts val="800"/>
+                <a:spcPts val="600"/>
               </a:spcAft>
             </a:pPr>
             <a:r>
-              <a:rPr sz="1300" b="0" i="0">
-                <a:solidFill>
-                  <a:srgbClr val="EAF1F8"/>
-                </a:solidFill>
-                <a:latin typeface="Segoe UI"/>
-              </a:rPr>
-              <a:t>Technical: </a:t>
-            </a:r>
-            <a:r>
-              <a:rPr sz="1300" b="0" i="0">
-                <a:solidFill>
-                  <a:srgbClr val="F2C45A"/>
-                </a:solidFill>
-                <a:latin typeface="Segoe UI"/>
-              </a:rPr>
-              <a:t>-0.85</a:t>
-            </a:r>
-            <a:r>
-              <a:rPr sz="1300" b="0" i="0">
-                <a:solidFill>
-                  <a:srgbClr val="EAF1F8"/>
-                </a:solidFill>
-                <a:latin typeface="Segoe UI"/>
-              </a:rPr>
-              <a:t>   Fundamentals: </a:t>
-            </a:r>
-            <a:r>
-              <a:rPr sz="1300" b="0" i="0">
-                <a:solidFill>
-                  <a:srgbClr val="F2C45A"/>
-                </a:solidFill>
-                <a:latin typeface="Segoe UI"/>
-              </a:rPr>
-              <a:t>+0.90</a:t>
-            </a:r>
-          </a:p>
-          <a:p>
-            <a:pPr algn="l">
-              <a:spcAft>
-                <a:spcPts val="800"/>
-              </a:spcAft>
-            </a:pPr>
-            <a:r>
-              <a:rPr sz="1300" b="0" i="0">
-                <a:solidFill>
-                  <a:srgbClr val="EAF1F8"/>
-                </a:solidFill>
-                <a:latin typeface="Segoe UI"/>
-              </a:rPr>
-              <a:t>Conflict: </a:t>
-            </a:r>
-            <a:r>
-              <a:rPr sz="1300" b="0" i="0">
-                <a:solidFill>
-                  <a:srgbClr val="F2C45A"/>
-                </a:solidFill>
-                <a:latin typeface="Segoe UI"/>
-              </a:rPr>
-              <a:t>weak price trend vs strong growth &amp; margins</a:t>
-            </a:r>
-          </a:p>
-          <a:p>
-            <a:pPr algn="l">
-              <a:spcAft>
-                <a:spcPts val="800"/>
-              </a:spcAft>
-            </a:pPr>
-            <a:r>
-              <a:rPr sz="1300" b="0" i="0">
-                <a:solidFill>
-                  <a:srgbClr val="EAF1F8"/>
-                </a:solidFill>
-                <a:latin typeface="Segoe UI"/>
-              </a:rPr>
-              <a:t>Manager's call: </a:t>
-            </a:r>
-            <a:r>
-              <a:rPr sz="1300" b="0" i="0">
-                <a:solidFill>
-                  <a:srgbClr val="F2C45A"/>
-                </a:solidFill>
-                <a:latin typeface="Segoe UI"/>
-              </a:rPr>
-              <a:t>8%</a:t>
-            </a:r>
-            <a:r>
-              <a:rPr sz="1300" b="0" i="0">
-                <a:solidFill>
-                  <a:srgbClr val="EAF1F8"/>
-                </a:solidFill>
-                <a:latin typeface="Segoe UI"/>
-              </a:rPr>
-              <a:t> — sized down, not cut, until the trend confirms</a:t>
-            </a:r>
-          </a:p>
-        </p:txBody>
-      </p:sp>
-      <p:sp>
-        <p:nvSpPr>
-          <p:cNvPr id="19" name="Rounded Rectangle 18"/>
+              <a:rPr sz="1200" b="0" i="0">
+                <a:solidFill>
+                  <a:srgbClr val="9FB0C0"/>
+                </a:solidFill>
+                <a:latin typeface="Segoe UI"/>
+              </a:rPr>
+              <a:t>Nothing dated after the cutoff reaches an agent. A leakage test scans every output and fails the run if a later date appears.</a:t>
+            </a:r>
+          </a:p>
+        </p:txBody>
+      </p:sp>
+      <p:sp>
+        <p:nvSpPr>
+          <p:cNvPr id="20" name="Rounded Rectangle 19"/>
           <p:cNvSpPr/>
           <p:nvPr/>
         </p:nvSpPr>
         <p:spPr>
           <a:xfrm>
-            <a:off x="6153912" y="3611880"/>
-            <a:ext cx="5394960" cy="2377440"/>
+            <a:off x="4334256" y="3611880"/>
+            <a:ext cx="3529584" cy="2286000"/>
           </a:xfrm>
           <a:prstGeom prst="roundRect">
             <a:avLst>
-              <a:gd name="adj" fmla="val 6000"/>
+              <a:gd name="adj" fmla="val 5000"/>
             </a:avLst>
           </a:prstGeom>
           <a:solidFill>
-            <a:srgbClr val="13263A"/>
+            <a:srgbClr val="142438"/>
           </a:solidFill>
           <a:ln w="25400">
             <a:solidFill>
@@ -5324,14 +5501,14 @@
       </p:sp>
       <p:sp>
         <p:nvSpPr>
-          <p:cNvPr id="20" name="TextBox 19"/>
+          <p:cNvPr id="21" name="TextBox 20"/>
           <p:cNvSpPr txBox="1"/>
           <p:nvPr/>
         </p:nvSpPr>
         <p:spPr>
           <a:xfrm>
-            <a:off x="6382512" y="3794760"/>
-            <a:ext cx="4937760" cy="2103120"/>
+            <a:off x="4517136" y="3730752"/>
+            <a:ext cx="3163824" cy="2103120"/>
           </a:xfrm>
           <a:prstGeom prst="rect">
             <a:avLst/>
@@ -5345,66 +5522,227 @@
           <a:lstStyle/>
           <a:p>
             <a:pPr algn="l">
+              <a:lnSpc>
+                <a:spcPct val="108000"/>
+              </a:lnSpc>
               <a:spcAft>
-                <a:spcPts val="800"/>
+                <a:spcPts val="600"/>
               </a:spcAft>
             </a:pPr>
             <a:r>
-              <a:rPr sz="1500" b="1" i="0">
+              <a:rPr sz="1450" b="1" i="0">
                 <a:solidFill>
                   <a:srgbClr val="EAF1F8"/>
                 </a:solidFill>
                 <a:latin typeface="Segoe UI"/>
               </a:rPr>
-              <a:t>Traceable by construction</a:t>
-            </a:r>
-          </a:p>
+              <a:t>Show the sources</a:t>
+            </a:r>
+          </a:p>
+          <a:p>
+            <a:pPr algn="l">
+              <a:lnSpc>
+                <a:spcPct val="108000"/>
+              </a:lnSpc>
+              <a:spcAft>
+                <a:spcPts val="600"/>
+              </a:spcAft>
+            </a:pPr>
+            <a:r>
+              <a:rPr sz="1200" b="0" i="0">
+                <a:solidFill>
+                  <a:srgbClr val="9FB0C0"/>
+                </a:solidFill>
+                <a:latin typeface="Segoe UI"/>
+              </a:rPr>
+              <a:t>Every claim cites an evidence ID. A validator rejects any ID not in the pack, so no number is unsupported.</a:t>
+            </a:r>
+          </a:p>
+        </p:txBody>
+      </p:sp>
+      <p:sp>
+        <p:nvSpPr>
+          <p:cNvPr id="22" name="Rounded Rectangle 21"/>
+          <p:cNvSpPr/>
+          <p:nvPr/>
+        </p:nvSpPr>
+        <p:spPr>
+          <a:xfrm>
+            <a:off x="8028432" y="3611880"/>
+            <a:ext cx="3529584" cy="2286000"/>
+          </a:xfrm>
+          <a:prstGeom prst="roundRect">
+            <a:avLst>
+              <a:gd name="adj" fmla="val 5000"/>
+            </a:avLst>
+          </a:prstGeom>
+          <a:solidFill>
+            <a:srgbClr val="142438"/>
+          </a:solidFill>
+          <a:ln w="25400">
+            <a:solidFill>
+              <a:srgbClr val="9B3F7E"/>
+            </a:solidFill>
+          </a:ln>
+          <a:effectLst/>
+        </p:spPr>
+        <p:style>
+          <a:lnRef idx="1">
+            <a:schemeClr val="accent1"/>
+          </a:lnRef>
+          <a:fillRef idx="3">
+            <a:schemeClr val="accent1"/>
+          </a:fillRef>
+          <a:effectRef idx="2">
+            <a:schemeClr val="accent1"/>
+          </a:effectRef>
+          <a:fontRef idx="minor">
+            <a:schemeClr val="lt1"/>
+          </a:fontRef>
+        </p:style>
+        <p:txBody>
+          <a:bodyPr rtlCol="0" anchor="ctr"/>
+          <a:lstStyle/>
+          <a:p>
+            <a:pPr algn="ctr"/>
+          </a:p>
+        </p:txBody>
+      </p:sp>
+      <p:sp>
+        <p:nvSpPr>
+          <p:cNvPr id="23" name="TextBox 22"/>
+          <p:cNvSpPr txBox="1"/>
+          <p:nvPr/>
+        </p:nvSpPr>
+        <p:spPr>
+          <a:xfrm>
+            <a:off x="8211312" y="3730752"/>
+            <a:ext cx="3163824" cy="2103120"/>
+          </a:xfrm>
+          <a:prstGeom prst="rect">
+            <a:avLst/>
+          </a:prstGeom>
+          <a:noFill/>
+        </p:spPr>
+        <p:txBody>
+          <a:bodyPr wrap="square" anchor="t">
+            <a:spAutoFit/>
+          </a:bodyPr>
+          <a:lstStyle/>
+          <a:p>
+            <a:pPr algn="l">
+              <a:lnSpc>
+                <a:spcPct val="108000"/>
+              </a:lnSpc>
+              <a:spcAft>
+                <a:spcPts val="600"/>
+              </a:spcAft>
+            </a:pPr>
+            <a:r>
+              <a:rPr sz="1450" b="1" i="0">
+                <a:solidFill>
+                  <a:srgbClr val="EAF1F8"/>
+                </a:solidFill>
+                <a:latin typeface="Segoe UI"/>
+              </a:rPr>
+              <a:t>Score once</a:t>
+            </a:r>
+          </a:p>
+          <a:p>
+            <a:pPr algn="l">
+              <a:lnSpc>
+                <a:spcPct val="108000"/>
+              </a:lnSpc>
+              <a:spcAft>
+                <a:spcPts val="600"/>
+              </a:spcAft>
+            </a:pPr>
+            <a:r>
+              <a:rPr sz="1200" b="0" i="0">
+                <a:solidFill>
+                  <a:srgbClr val="9FB0C0"/>
+                </a:solidFill>
+                <a:latin typeface="Segoe UI"/>
+              </a:rPr>
+              <a:t>Tune on an earlier cutoff, freeze prompts and data, cache every model call, then run the final window exactly once.</a:t>
+            </a:r>
+          </a:p>
+        </p:txBody>
+      </p:sp>
+      <p:sp>
+        <p:nvSpPr>
+          <p:cNvPr id="24" name="TextBox 23"/>
+          <p:cNvSpPr txBox="1"/>
+          <p:nvPr/>
+        </p:nvSpPr>
+        <p:spPr>
+          <a:xfrm>
+            <a:off x="502920" y="6446520"/>
+            <a:ext cx="9144000" cy="274320"/>
+          </a:xfrm>
+          <a:prstGeom prst="rect">
+            <a:avLst/>
+          </a:prstGeom>
+          <a:noFill/>
+        </p:spPr>
+        <p:txBody>
+          <a:bodyPr wrap="square" anchor="t">
+            <a:spAutoFit/>
+          </a:bodyPr>
+          <a:lstStyle/>
           <a:p>
             <a:pPr algn="l">
               <a:spcAft>
-                <a:spcPts val="800"/>
+                <a:spcPts val="500"/>
               </a:spcAft>
             </a:pPr>
             <a:r>
-              <a:rPr sz="1300" b="0" i="0">
-                <a:solidFill>
-                  <a:srgbClr val="9FB0C0"/>
-                </a:solidFill>
-                <a:latin typeface="Segoe UI"/>
-              </a:rPr>
-              <a:t>•  weights sum to 1, caps enforced in code</a:t>
-            </a:r>
-          </a:p>
-          <a:p>
-            <a:pPr algn="l">
+              <a:rPr sz="800" b="0" i="0">
+                <a:solidFill>
+                  <a:srgbClr val="5A6D80"/>
+                </a:solidFill>
+                <a:latin typeface="Segoe UI"/>
+              </a:rPr>
+              <a:t>Multi-agent portfolio research · Austin Agentic AI Hackathon · historical experiment, not financial advice</a:t>
+            </a:r>
+          </a:p>
+        </p:txBody>
+      </p:sp>
+      <p:sp>
+        <p:nvSpPr>
+          <p:cNvPr id="25" name="TextBox 24"/>
+          <p:cNvSpPr txBox="1"/>
+          <p:nvPr/>
+        </p:nvSpPr>
+        <p:spPr>
+          <a:xfrm>
+            <a:off x="11338560" y="6446520"/>
+            <a:ext cx="548640" cy="274320"/>
+          </a:xfrm>
+          <a:prstGeom prst="rect">
+            <a:avLst/>
+          </a:prstGeom>
+          <a:noFill/>
+        </p:spPr>
+        <p:txBody>
+          <a:bodyPr wrap="square" anchor="t">
+            <a:spAutoFit/>
+          </a:bodyPr>
+          <a:lstStyle/>
+          <a:p>
+            <a:pPr algn="r">
               <a:spcAft>
-                <a:spcPts val="800"/>
+                <a:spcPts val="500"/>
               </a:spcAft>
             </a:pPr>
             <a:r>
-              <a:rPr sz="1300" b="0" i="0">
+              <a:rPr sz="900" b="0" i="0">
                 <a:solidFill>
                   <a:srgbClr val="9FB0C0"/>
                 </a:solidFill>
                 <a:latin typeface="Segoe UI"/>
               </a:rPr>
-              <a:t>•  cited IDs must exist in the evidence pack</a:t>
-            </a:r>
-          </a:p>
-          <a:p>
-            <a:pPr algn="l">
-              <a:spcAft>
-                <a:spcPts val="800"/>
-              </a:spcAft>
-            </a:pPr>
-            <a:r>
-              <a:rPr sz="1300" b="0" i="0">
-                <a:solidFill>
-                  <a:srgbClr val="9FB0C0"/>
-                </a:solidFill>
-                <a:latin typeface="Segoe UI"/>
-              </a:rPr>
-              <a:t>•  re-prompt once, then deterministic repair</a:t>
+              <a:t>2</a:t>
             </a:r>
           </a:p>
         </p:txBody>
@@ -5442,7 +5780,7 @@
             <a:avLst/>
           </a:prstGeom>
           <a:solidFill>
-            <a:srgbClr val="0B1522"/>
+            <a:srgbClr val="0A121F"/>
           </a:solidFill>
           <a:ln>
             <a:noFill/>
@@ -5479,14 +5817,14 @@
         </p:nvSpPr>
         <p:spPr>
           <a:xfrm>
-            <a:off x="640080" y="1078992"/>
-            <a:ext cx="2011680" cy="38100"/>
+            <a:off x="0" y="0"/>
+            <a:ext cx="109728" cy="6858000"/>
           </a:xfrm>
           <a:prstGeom prst="rect">
             <a:avLst/>
           </a:prstGeom>
           <a:solidFill>
-            <a:srgbClr val="F2C45A"/>
+            <a:srgbClr val="FF9900"/>
           </a:solidFill>
           <a:ln>
             <a:noFill/>
@@ -5523,8 +5861,8 @@
         </p:nvSpPr>
         <p:spPr>
           <a:xfrm>
-            <a:off x="640080" y="411480"/>
-            <a:ext cx="10972800" cy="640080"/>
+            <a:off x="502920" y="274320"/>
+            <a:ext cx="10058400" cy="365760"/>
           </a:xfrm>
           <a:prstGeom prst="rect">
             <a:avLst/>
@@ -5539,435 +5877,31 @@
           <a:p>
             <a:pPr algn="l">
               <a:spcAft>
-                <a:spcPts val="400"/>
+                <a:spcPts val="500"/>
               </a:spcAft>
             </a:pPr>
             <a:r>
-              <a:rPr sz="3000" b="1" i="0">
-                <a:solidFill>
-                  <a:srgbClr val="EAF1F8"/>
-                </a:solidFill>
-                <a:latin typeface="Segoe UI"/>
-              </a:rPr>
-              <a:t>What happened</a:t>
-            </a:r>
-          </a:p>
-        </p:txBody>
-      </p:sp>
-      <p:graphicFrame>
-        <p:nvGraphicFramePr>
-          <p:cNvPr id="5" name="Table 4"/>
-          <p:cNvGraphicFramePr>
-            <a:graphicFrameLocks noGrp="1"/>
-          </p:cNvGraphicFramePr>
-          <p:nvPr/>
-        </p:nvGraphicFramePr>
-        <p:xfrm>
-          <a:off x="640080" y="1188720"/>
-          <a:ext cx="10908792" cy="1920240"/>
-        </p:xfrm>
-        <a:graphic>
-          <a:graphicData uri="http://schemas.openxmlformats.org/drawingml/2006/table">
-            <a:tbl>
-              <a:tblPr firstRow="1" bandRow="1">
-                <a:tableStyleId>{5C22544A-7EE6-4342-B048-85BDC9FD1C3A}</a:tableStyleId>
-              </a:tblPr>
-              <a:tblGrid>
-                <a:gridCol w="3474720"/>
-                <a:gridCol w="2478024"/>
-                <a:gridCol w="2478024"/>
-                <a:gridCol w="2478024"/>
-              </a:tblGrid>
-              <a:tr h="480060">
-                <a:tc>
-                  <a:txBody>
-                    <a:bodyPr/>
-                    <a:lstStyle/>
-                    <a:p>
-                      <a:pPr algn="l"/>
-                      <a:r>
-                        <a:rPr sz="1300" b="1" i="0">
-                          <a:solidFill>
-                            <a:srgbClr val="EAF1F8"/>
-                          </a:solidFill>
-                          <a:latin typeface="Segoe UI"/>
-                        </a:rPr>
-                        <a:t>Metric</a:t>
-                      </a:r>
-                    </a:p>
-                  </a:txBody>
-                  <a:tcPr marT="38100" marB="38100" marL="101600" marR="101600" anchor="ctr">
-                    <a:solidFill>
-                      <a:srgbClr val="1B5FA8"/>
-                    </a:solidFill>
-                  </a:tcPr>
-                </a:tc>
-                <a:tc>
-                  <a:txBody>
-                    <a:bodyPr/>
-                    <a:lstStyle/>
-                    <a:p>
-                      <a:pPr algn="ctr"/>
-                      <a:r>
-                        <a:rPr sz="1300" b="1" i="0">
-                          <a:solidFill>
-                            <a:srgbClr val="EAF1F8"/>
-                          </a:solidFill>
-                          <a:latin typeface="Segoe UI"/>
-                        </a:rPr>
-                        <a:t>Portfolio</a:t>
-                      </a:r>
-                    </a:p>
-                  </a:txBody>
-                  <a:tcPr marT="38100" marB="38100" marL="101600" marR="101600" anchor="ctr">
-                    <a:solidFill>
-                      <a:srgbClr val="1B5FA8"/>
-                    </a:solidFill>
-                  </a:tcPr>
-                </a:tc>
-                <a:tc>
-                  <a:txBody>
-                    <a:bodyPr/>
-                    <a:lstStyle/>
-                    <a:p>
-                      <a:pPr algn="ctr"/>
-                      <a:r>
-                        <a:rPr sz="1300" b="1" i="0">
-                          <a:solidFill>
-                            <a:srgbClr val="EAF1F8"/>
-                          </a:solidFill>
-                          <a:latin typeface="Segoe UI"/>
-                        </a:rPr>
-                        <a:t>SPY</a:t>
-                      </a:r>
-                    </a:p>
-                  </a:txBody>
-                  <a:tcPr marT="38100" marB="38100" marL="101600" marR="101600" anchor="ctr">
-                    <a:solidFill>
-                      <a:srgbClr val="1B5FA8"/>
-                    </a:solidFill>
-                  </a:tcPr>
-                </a:tc>
-                <a:tc>
-                  <a:txBody>
-                    <a:bodyPr/>
-                    <a:lstStyle/>
-                    <a:p>
-                      <a:pPr algn="ctr"/>
-                      <a:r>
-                        <a:rPr sz="1300" b="1" i="0">
-                          <a:solidFill>
-                            <a:srgbClr val="EAF1F8"/>
-                          </a:solidFill>
-                          <a:latin typeface="Segoe UI"/>
-                        </a:rPr>
-                        <a:t>Equal weight</a:t>
-                      </a:r>
-                    </a:p>
-                  </a:txBody>
-                  <a:tcPr marT="38100" marB="38100" marL="101600" marR="101600" anchor="ctr">
-                    <a:solidFill>
-                      <a:srgbClr val="1B5FA8"/>
-                    </a:solidFill>
-                  </a:tcPr>
-                </a:tc>
-              </a:tr>
-              <a:tr h="480060">
-                <a:tc>
-                  <a:txBody>
-                    <a:bodyPr/>
-                    <a:lstStyle/>
-                    <a:p>
-                      <a:pPr algn="l"/>
-                      <a:r>
-                        <a:rPr sz="1300" b="0" i="0">
-                          <a:solidFill>
-                            <a:srgbClr val="EAF1F8"/>
-                          </a:solidFill>
-                          <a:latin typeface="Segoe UI"/>
-                        </a:rPr>
-                        <a:t>Total return</a:t>
-                      </a:r>
-                    </a:p>
-                  </a:txBody>
-                  <a:tcPr marT="38100" marB="38100" marL="101600" marR="101600" anchor="ctr">
-                    <a:solidFill>
-                      <a:srgbClr val="13263A"/>
-                    </a:solidFill>
-                  </a:tcPr>
-                </a:tc>
-                <a:tc>
-                  <a:txBody>
-                    <a:bodyPr/>
-                    <a:lstStyle/>
-                    <a:p>
-                      <a:pPr algn="ctr"/>
-                      <a:r>
-                        <a:rPr sz="1300" b="0" i="0">
-                          <a:solidFill>
-                            <a:srgbClr val="F2C45A"/>
-                          </a:solidFill>
-                          <a:latin typeface="Segoe UI"/>
-                        </a:rPr>
-                        <a:t>16.7%</a:t>
-                      </a:r>
-                    </a:p>
-                  </a:txBody>
-                  <a:tcPr marT="38100" marB="38100" marL="101600" marR="101600" anchor="ctr">
-                    <a:solidFill>
-                      <a:srgbClr val="13263A"/>
-                    </a:solidFill>
-                  </a:tcPr>
-                </a:tc>
-                <a:tc>
-                  <a:txBody>
-                    <a:bodyPr/>
-                    <a:lstStyle/>
-                    <a:p>
-                      <a:pPr algn="ctr"/>
-                      <a:r>
-                        <a:rPr sz="1300" b="0" i="0">
-                          <a:solidFill>
-                            <a:srgbClr val="EAF1F8"/>
-                          </a:solidFill>
-                          <a:latin typeface="Segoe UI"/>
-                        </a:rPr>
-                        <a:t>11.2%</a:t>
-                      </a:r>
-                    </a:p>
-                  </a:txBody>
-                  <a:tcPr marT="38100" marB="38100" marL="101600" marR="101600" anchor="ctr">
-                    <a:solidFill>
-                      <a:srgbClr val="13263A"/>
-                    </a:solidFill>
-                  </a:tcPr>
-                </a:tc>
-                <a:tc>
-                  <a:txBody>
-                    <a:bodyPr/>
-                    <a:lstStyle/>
-                    <a:p>
-                      <a:pPr algn="ctr"/>
-                      <a:r>
-                        <a:rPr sz="1300" b="0" i="0">
-                          <a:solidFill>
-                            <a:srgbClr val="EAF1F8"/>
-                          </a:solidFill>
-                          <a:latin typeface="Segoe UI"/>
-                        </a:rPr>
-                        <a:t>15.5%</a:t>
-                      </a:r>
-                    </a:p>
-                  </a:txBody>
-                  <a:tcPr marT="38100" marB="38100" marL="101600" marR="101600" anchor="ctr">
-                    <a:solidFill>
-                      <a:srgbClr val="13263A"/>
-                    </a:solidFill>
-                  </a:tcPr>
-                </a:tc>
-              </a:tr>
-              <a:tr h="480060">
-                <a:tc>
-                  <a:txBody>
-                    <a:bodyPr/>
-                    <a:lstStyle/>
-                    <a:p>
-                      <a:pPr algn="l"/>
-                      <a:r>
-                        <a:rPr sz="1300" b="0" i="0">
-                          <a:solidFill>
-                            <a:srgbClr val="EAF1F8"/>
-                          </a:solidFill>
-                          <a:latin typeface="Segoe UI"/>
-                        </a:rPr>
-                        <a:t>Sharpe</a:t>
-                      </a:r>
-                    </a:p>
-                  </a:txBody>
-                  <a:tcPr marT="38100" marB="38100" marL="101600" marR="101600" anchor="ctr">
-                    <a:solidFill>
-                      <a:srgbClr val="13263A"/>
-                    </a:solidFill>
-                  </a:tcPr>
-                </a:tc>
-                <a:tc>
-                  <a:txBody>
-                    <a:bodyPr/>
-                    <a:lstStyle/>
-                    <a:p>
-                      <a:pPr algn="ctr"/>
-                      <a:r>
-                        <a:rPr sz="1300" b="0" i="0">
-                          <a:solidFill>
-                            <a:srgbClr val="F2C45A"/>
-                          </a:solidFill>
-                          <a:latin typeface="Segoe UI"/>
-                        </a:rPr>
-                        <a:t>2.37</a:t>
-                      </a:r>
-                    </a:p>
-                  </a:txBody>
-                  <a:tcPr marT="38100" marB="38100" marL="101600" marR="101600" anchor="ctr">
-                    <a:solidFill>
-                      <a:srgbClr val="13263A"/>
-                    </a:solidFill>
-                  </a:tcPr>
-                </a:tc>
-                <a:tc>
-                  <a:txBody>
-                    <a:bodyPr/>
-                    <a:lstStyle/>
-                    <a:p>
-                      <a:pPr algn="ctr"/>
-                      <a:r>
-                        <a:rPr sz="1300" b="0" i="0">
-                          <a:solidFill>
-                            <a:srgbClr val="EAF1F8"/>
-                          </a:solidFill>
-                          <a:latin typeface="Segoe UI"/>
-                        </a:rPr>
-                        <a:t>1.19</a:t>
-                      </a:r>
-                    </a:p>
-                  </a:txBody>
-                  <a:tcPr marT="38100" marB="38100" marL="101600" marR="101600" anchor="ctr">
-                    <a:solidFill>
-                      <a:srgbClr val="13263A"/>
-                    </a:solidFill>
-                  </a:tcPr>
-                </a:tc>
-                <a:tc>
-                  <a:txBody>
-                    <a:bodyPr/>
-                    <a:lstStyle/>
-                    <a:p>
-                      <a:pPr algn="ctr"/>
-                      <a:r>
-                        <a:rPr sz="1300" b="0" i="0">
-                          <a:solidFill>
-                            <a:srgbClr val="EAF1F8"/>
-                          </a:solidFill>
-                          <a:latin typeface="Segoe UI"/>
-                        </a:rPr>
-                        <a:t>2.02</a:t>
-                      </a:r>
-                    </a:p>
-                  </a:txBody>
-                  <a:tcPr marT="38100" marB="38100" marL="101600" marR="101600" anchor="ctr">
-                    <a:solidFill>
-                      <a:srgbClr val="13263A"/>
-                    </a:solidFill>
-                  </a:tcPr>
-                </a:tc>
-              </a:tr>
-              <a:tr h="480060">
-                <a:tc>
-                  <a:txBody>
-                    <a:bodyPr/>
-                    <a:lstStyle/>
-                    <a:p>
-                      <a:pPr algn="l"/>
-                      <a:r>
-                        <a:rPr sz="1300" b="0" i="0">
-                          <a:solidFill>
-                            <a:srgbClr val="EAF1F8"/>
-                          </a:solidFill>
-                          <a:latin typeface="Segoe UI"/>
-                        </a:rPr>
-                        <a:t>Max drawdown</a:t>
-                      </a:r>
-                    </a:p>
-                  </a:txBody>
-                  <a:tcPr marT="38100" marB="38100" marL="101600" marR="101600" anchor="ctr">
-                    <a:solidFill>
-                      <a:srgbClr val="13263A"/>
-                    </a:solidFill>
-                  </a:tcPr>
-                </a:tc>
-                <a:tc>
-                  <a:txBody>
-                    <a:bodyPr/>
-                    <a:lstStyle/>
-                    <a:p>
-                      <a:pPr algn="ctr"/>
-                      <a:r>
-                        <a:rPr sz="1300" b="0" i="0">
-                          <a:solidFill>
-                            <a:srgbClr val="F2C45A"/>
-                          </a:solidFill>
-                          <a:latin typeface="Segoe UI"/>
-                        </a:rPr>
-                        <a:t>-5.3%</a:t>
-                      </a:r>
-                    </a:p>
-                  </a:txBody>
-                  <a:tcPr marT="38100" marB="38100" marL="101600" marR="101600" anchor="ctr">
-                    <a:solidFill>
-                      <a:srgbClr val="13263A"/>
-                    </a:solidFill>
-                  </a:tcPr>
-                </a:tc>
-                <a:tc>
-                  <a:txBody>
-                    <a:bodyPr/>
-                    <a:lstStyle/>
-                    <a:p>
-                      <a:pPr algn="ctr"/>
-                      <a:r>
-                        <a:rPr sz="1300" b="0" i="0">
-                          <a:solidFill>
-                            <a:srgbClr val="EAF1F8"/>
-                          </a:solidFill>
-                          <a:latin typeface="Segoe UI"/>
-                        </a:rPr>
-                        <a:t>-8.9%</a:t>
-                      </a:r>
-                    </a:p>
-                  </a:txBody>
-                  <a:tcPr marT="38100" marB="38100" marL="101600" marR="101600" anchor="ctr">
-                    <a:solidFill>
-                      <a:srgbClr val="13263A"/>
-                    </a:solidFill>
-                  </a:tcPr>
-                </a:tc>
-                <a:tc>
-                  <a:txBody>
-                    <a:bodyPr/>
-                    <a:lstStyle/>
-                    <a:p>
-                      <a:pPr algn="ctr"/>
-                      <a:r>
-                        <a:rPr sz="1300" b="0" i="0">
-                          <a:solidFill>
-                            <a:srgbClr val="EAF1F8"/>
-                          </a:solidFill>
-                          <a:latin typeface="Segoe UI"/>
-                        </a:rPr>
-                        <a:t>-6.1%</a:t>
-                      </a:r>
-                    </a:p>
-                  </a:txBody>
-                  <a:tcPr marT="38100" marB="38100" marL="101600" marR="101600" anchor="ctr">
-                    <a:solidFill>
-                      <a:srgbClr val="13263A"/>
-                    </a:solidFill>
-                  </a:tcPr>
-                </a:tc>
-              </a:tr>
-            </a:tbl>
-          </a:graphicData>
-        </a:graphic>
-      </p:graphicFrame>
-      <p:sp>
-        <p:nvSpPr>
-          <p:cNvPr id="6" name="TextBox 5"/>
+              <a:rPr sz="1200" b="1" i="0">
+                <a:solidFill>
+                  <a:srgbClr val="FF9900"/>
+                </a:solidFill>
+                <a:latin typeface="Segoe UI"/>
+              </a:rPr>
+              <a:t>REASONING, OPENED UP</a:t>
+            </a:r>
+          </a:p>
+        </p:txBody>
+      </p:sp>
+      <p:sp>
+        <p:nvSpPr>
+          <p:cNvPr id="5" name="TextBox 4"/>
           <p:cNvSpPr txBox="1"/>
           <p:nvPr/>
         </p:nvSpPr>
         <p:spPr>
           <a:xfrm>
-            <a:off x="640080" y="3200400"/>
-            <a:ext cx="10908792" cy="457200"/>
+            <a:off x="502920" y="658368"/>
+            <a:ext cx="11155680" cy="731520"/>
           </a:xfrm>
           <a:prstGeom prst="rect">
             <a:avLst/>
@@ -5982,17 +5916,59 @@
           <a:p>
             <a:pPr algn="l">
               <a:spcAft>
-                <a:spcPts val="400"/>
+                <a:spcPts val="500"/>
               </a:spcAft>
             </a:pPr>
             <a:r>
-              <a:rPr sz="1150" b="0" i="1">
+              <a:rPr sz="2900" b="1" i="0">
+                <a:solidFill>
+                  <a:srgbClr val="EAF1F8"/>
+                </a:solidFill>
+                <a:latin typeface="Segoe UI"/>
+              </a:rPr>
+              <a:t>One decision: MSFT, where the analysts disagree most</a:t>
+            </a:r>
+          </a:p>
+        </p:txBody>
+      </p:sp>
+      <p:sp>
+        <p:nvSpPr>
+          <p:cNvPr id="6" name="TextBox 5"/>
+          <p:cNvSpPr txBox="1"/>
+          <p:nvPr/>
+        </p:nvSpPr>
+        <p:spPr>
+          <a:xfrm>
+            <a:off x="502920" y="1371600"/>
+            <a:ext cx="11155680" cy="685800"/>
+          </a:xfrm>
+          <a:prstGeom prst="rect">
+            <a:avLst/>
+          </a:prstGeom>
+          <a:noFill/>
+        </p:spPr>
+        <p:txBody>
+          <a:bodyPr wrap="square" anchor="t">
+            <a:spAutoFit/>
+          </a:bodyPr>
+          <a:lstStyle/>
+          <a:p>
+            <a:pPr algn="l">
+              <a:lnSpc>
+                <a:spcPct val="110000"/>
+              </a:lnSpc>
+              <a:spcAft>
+                <a:spcPts val="500"/>
+              </a:spcAft>
+            </a:pPr>
+            <a:r>
+              <a:rPr sz="1400" b="0" i="0">
                 <a:solidFill>
                   <a:srgbClr val="9FB0C0"/>
                 </a:solidFill>
                 <a:latin typeface="Segoe UI"/>
               </a:rPr>
-              <a:t>Beats SPY on every measure, statistically close to equal weight. Beating the market isn't required - explaining the result and testing it against the baselines is.</a:t>
+              <a:t>We pick the deep-dive by rule before seeing any result: the position with the widest analyst disagreement. That is MSFT, and it shows the system reconciling a real conflict rather than rubber-stamping a consensus.</a:t>
             </a:r>
           </a:p>
         </p:txBody>
@@ -6005,20 +5981,20 @@
         </p:nvSpPr>
         <p:spPr>
           <a:xfrm>
-            <a:off x="640080" y="3794760"/>
-            <a:ext cx="5394960" cy="2011680"/>
+            <a:off x="502920" y="2331720"/>
+            <a:ext cx="5486400" cy="3520440"/>
           </a:xfrm>
           <a:prstGeom prst="roundRect">
             <a:avLst>
-              <a:gd name="adj" fmla="val 6000"/>
+              <a:gd name="adj" fmla="val 5000"/>
             </a:avLst>
           </a:prstGeom>
           <a:solidFill>
-            <a:srgbClr val="13263A"/>
+            <a:srgbClr val="142438"/>
           </a:solidFill>
           <a:ln w="25400">
             <a:solidFill>
-              <a:srgbClr val="1B5FA8"/>
+              <a:srgbClr val="9B3F7E"/>
             </a:solidFill>
           </a:ln>
           <a:effectLst/>
@@ -6053,8 +6029,8 @@
         </p:nvSpPr>
         <p:spPr>
           <a:xfrm>
-            <a:off x="868680" y="3959352"/>
-            <a:ext cx="4937760" cy="1737360"/>
+            <a:off x="731520" y="2450592"/>
+            <a:ext cx="5029200" cy="3291840"/>
           </a:xfrm>
           <a:prstGeom prst="rect">
             <a:avLst/>
@@ -6068,66 +6044,132 @@
           <a:lstStyle/>
           <a:p>
             <a:pPr algn="l">
+              <a:lnSpc>
+                <a:spcPct val="108000"/>
+              </a:lnSpc>
               <a:spcAft>
-                <a:spcPts val="800"/>
+                <a:spcPts val="1000"/>
               </a:spcAft>
             </a:pPr>
             <a:r>
-              <a:rPr sz="1500" b="1" i="0">
+              <a:rPr sz="1450" b="1" i="0">
                 <a:solidFill>
                   <a:srgbClr val="EAF1F8"/>
                 </a:solidFill>
                 <a:latin typeface="Segoe UI"/>
               </a:rPr>
-              <a:t>Why trust it</a:t>
+              <a:t>The conflict (spread 0.78, widest in the universe)</a:t>
             </a:r>
           </a:p>
           <a:p>
             <a:pPr algn="l">
+              <a:lnSpc>
+                <a:spcPct val="108000"/>
+              </a:lnSpc>
               <a:spcAft>
-                <a:spcPts val="800"/>
+                <a:spcPts val="1000"/>
               </a:spcAft>
             </a:pPr>
             <a:r>
               <a:rPr sz="1300" b="0" i="0">
                 <a:solidFill>
+                  <a:srgbClr val="EAF1F8"/>
+                </a:solidFill>
+                <a:latin typeface="Segoe UI"/>
+              </a:rPr>
+              <a:t>Fundamentals  </a:t>
+            </a:r>
+            <a:r>
+              <a:rPr sz="1300" b="1" i="0">
+                <a:solidFill>
+                  <a:srgbClr val="1C8A5E"/>
+                </a:solidFill>
+                <a:latin typeface="Segoe UI"/>
+              </a:rPr>
+              <a:t>+0.90</a:t>
+            </a:r>
+            <a:r>
+              <a:rPr sz="1200" b="0" i="0">
+                <a:solidFill>
                   <a:srgbClr val="9FB0C0"/>
                 </a:solidFill>
                 <a:latin typeface="Segoe UI"/>
               </a:rPr>
-              <a:t>•  leakage test on every run</a:t>
+              <a:t>  16.7% revenue growth, 20.9% operating-income growth, a 47% margin.</a:t>
             </a:r>
           </a:p>
           <a:p>
             <a:pPr algn="l">
+              <a:lnSpc>
+                <a:spcPct val="108000"/>
+              </a:lnSpc>
               <a:spcAft>
-                <a:spcPts val="800"/>
+                <a:spcPts val="1000"/>
               </a:spcAft>
             </a:pPr>
             <a:r>
               <a:rPr sz="1300" b="0" i="0">
                 <a:solidFill>
+                  <a:srgbClr val="EAF1F8"/>
+                </a:solidFill>
+                <a:latin typeface="Segoe UI"/>
+              </a:rPr>
+              <a:t>Technical  </a:t>
+            </a:r>
+            <a:r>
+              <a:rPr sz="1300" b="1" i="0">
+                <a:solidFill>
+                  <a:srgbClr val="D65A5A"/>
+                </a:solidFill>
+                <a:latin typeface="Segoe UI"/>
+              </a:rPr>
+              <a:t>-0.85</a:t>
+            </a:r>
+            <a:r>
+              <a:rPr sz="1200" b="0" i="0">
+                <a:solidFill>
                   <a:srgbClr val="9FB0C0"/>
                 </a:solidFill>
                 <a:latin typeface="Segoe UI"/>
               </a:rPr>
-              <a:t>•  one cached, reproducible final run</a:t>
+              <a:t>  a death cross, price below both moving averages, sharply negative momentum.</a:t>
             </a:r>
           </a:p>
           <a:p>
             <a:pPr algn="l">
+              <a:lnSpc>
+                <a:spcPct val="108000"/>
+              </a:lnSpc>
               <a:spcAft>
-                <a:spcPts val="800"/>
+                <a:spcPts val="1000"/>
               </a:spcAft>
             </a:pPr>
             <a:r>
               <a:rPr sz="1300" b="0" i="0">
                 <a:solidFill>
+                  <a:srgbClr val="EAF1F8"/>
+                </a:solidFill>
+                <a:latin typeface="Segoe UI"/>
+              </a:rPr>
+              <a:t>Sentiment  </a:t>
+            </a:r>
+            <a:r>
+              <a:rPr sz="1300" b="1" i="0">
+                <a:solidFill>
+                  <a:srgbClr val="7FA6CC"/>
+                </a:solidFill>
+                <a:latin typeface="Segoe UI"/>
+              </a:rPr>
+              <a:t>+0.25</a:t>
+            </a:r>
+            <a:r>
+              <a:rPr sz="1200" b="0" i="0">
+                <a:solidFill>
                   <a:srgbClr val="9FB0C0"/>
                 </a:solidFill>
                 <a:latin typeface="Segoe UI"/>
               </a:rPr>
-              <a:t>•  limitations stated, including model memory</a:t>
+              <a:t>  modestly constructive, but on weaker evidence.</a:t>
             </a:r>
           </a:p>
         </p:txBody>
@@ -6140,20 +6182,20 @@
         </p:nvSpPr>
         <p:spPr>
           <a:xfrm>
-            <a:off x="6153912" y="3794760"/>
-            <a:ext cx="5394960" cy="2011680"/>
+            <a:off x="6172200" y="2331720"/>
+            <a:ext cx="5486400" cy="3520440"/>
           </a:xfrm>
           <a:prstGeom prst="roundRect">
             <a:avLst>
-              <a:gd name="adj" fmla="val 6000"/>
+              <a:gd name="adj" fmla="val 5000"/>
             </a:avLst>
           </a:prstGeom>
           <a:solidFill>
-            <a:srgbClr val="13263A"/>
+            <a:srgbClr val="142438"/>
           </a:solidFill>
           <a:ln w="25400">
             <a:solidFill>
-              <a:srgbClr val="0E7A5F"/>
+              <a:srgbClr val="1B5FA8"/>
             </a:solidFill>
           </a:ln>
           <a:effectLst/>
@@ -6188,8 +6230,8 @@
         </p:nvSpPr>
         <p:spPr>
           <a:xfrm>
-            <a:off x="6382512" y="3959352"/>
-            <a:ext cx="4937760" cy="1737360"/>
+            <a:off x="6400800" y="2450592"/>
+            <a:ext cx="5029200" cy="3291840"/>
           </a:xfrm>
           <a:prstGeom prst="rect">
             <a:avLst/>
@@ -6203,77 +6245,87 @@
           <a:lstStyle/>
           <a:p>
             <a:pPr algn="l">
+              <a:lnSpc>
+                <a:spcPct val="107000"/>
+              </a:lnSpc>
               <a:spcAft>
-                <a:spcPts val="600"/>
+                <a:spcPts val="900"/>
               </a:spcAft>
             </a:pPr>
             <a:r>
-              <a:rPr sz="1500" b="1" i="0">
+              <a:rPr sz="1450" b="1" i="0">
                 <a:solidFill>
                   <a:srgbClr val="EAF1F8"/>
                 </a:solidFill>
                 <a:latin typeface="Segoe UI"/>
               </a:rPr>
-              <a:t>What's next </a:t>
-            </a:r>
-            <a:r>
-              <a:rPr sz="1200" b="1" i="0">
-                <a:solidFill>
-                  <a:srgbClr val="F2C45A"/>
-                </a:solidFill>
-                <a:latin typeface="Segoe UI"/>
-              </a:rPr>
-              <a:t>(stretch)</a:t>
+              <a:t>The call: 8% — underweight, not a cut</a:t>
             </a:r>
           </a:p>
           <a:p>
             <a:pPr algn="l">
+              <a:lnSpc>
+                <a:spcPct val="107000"/>
+              </a:lnSpc>
               <a:spcAft>
-                <a:spcPts val="600"/>
+                <a:spcPts val="900"/>
               </a:spcAft>
             </a:pPr>
             <a:r>
-              <a:rPr sz="1300" b="1" i="0">
-                <a:solidFill>
-                  <a:srgbClr val="EAF1F8"/>
-                </a:solidFill>
-                <a:latin typeface="Segoe UI"/>
-              </a:rPr>
-              <a:t>Risk management</a:t>
-            </a:r>
-            <a:r>
-              <a:rPr sz="1250" b="0" i="0">
+              <a:rPr sz="1200" b="0" i="0">
                 <a:solidFill>
                   <a:srgbClr val="9FB0C0"/>
                 </a:solidFill>
                 <a:latin typeface="Segoe UI"/>
               </a:rPr>
-              <a:t> — watch the portfolio, detect regime shifts, feed lessons back to the manager</a:t>
+              <a:t>The fundamental quality is compelling, but the technical downtrend is the clearest near-term risk and carries very high confidence. The manager keeps a starter position and lets cash absorb the uncertainty.</a:t>
             </a:r>
           </a:p>
           <a:p>
             <a:pPr algn="l">
+              <a:lnSpc>
+                <a:spcPct val="107000"/>
+              </a:lnSpc>
               <a:spcAft>
-                <a:spcPts val="600"/>
+                <a:spcPts val="900"/>
               </a:spcAft>
             </a:pPr>
             <a:r>
               <a:rPr sz="1300" b="1" i="0">
                 <a:solidFill>
-                  <a:srgbClr val="EAF1F8"/>
-                </a:solidFill>
-                <a:latin typeface="Segoe UI"/>
-              </a:rPr>
-              <a:t>CrashLab</a:t>
-            </a:r>
-            <a:r>
-              <a:rPr sz="1250" b="0" i="0">
+                  <a:srgbClr val="FF9900"/>
+                </a:solidFill>
+                <a:latin typeface="Segoe UI"/>
+              </a:rPr>
+              <a:t>Change triggers: </a:t>
+            </a:r>
+            <a:r>
+              <a:rPr sz="1200" b="0" i="0">
                 <a:solidFill>
                   <a:srgbClr val="9FB0C0"/>
                 </a:solidFill>
                 <a:latin typeface="Segoe UI"/>
               </a:rPr>
-              <a:t> — replay the weights through 2008, 2020 and invented shocks, propose protective changes</a:t>
+              <a:t>add if price reclaims the 200-day and momentum stabilises; cut if momentum worsens, revenue growth falls below 10%, or export controls broaden to advanced chips.</a:t>
+            </a:r>
+          </a:p>
+          <a:p>
+            <a:pPr algn="l">
+              <a:lnSpc>
+                <a:spcPct val="107000"/>
+              </a:lnSpc>
+              <a:spcAft>
+                <a:spcPts val="900"/>
+              </a:spcAft>
+            </a:pPr>
+            <a:r>
+              <a:rPr sz="1200" b="0" i="1">
+                <a:solidFill>
+                  <a:srgbClr val="1C8A5E"/>
+                </a:solidFill>
+                <a:latin typeface="Segoe UI"/>
+              </a:rPr>
+              <a:t>Every figure above is a cited, validated evidence ID.</a:t>
             </a:r>
           </a:p>
         </p:txBody>
@@ -6286,8 +6338,8 @@
         </p:nvSpPr>
         <p:spPr>
           <a:xfrm>
-            <a:off x="640080" y="5989320"/>
-            <a:ext cx="10908792" cy="457200"/>
+            <a:off x="502920" y="6446520"/>
+            <a:ext cx="9144000" cy="274320"/>
           </a:xfrm>
           <a:prstGeom prst="rect">
             <a:avLst/>
@@ -6300,9 +6352,1818 @@
           </a:bodyPr>
           <a:lstStyle/>
           <a:p>
+            <a:pPr algn="l">
+              <a:spcAft>
+                <a:spcPts val="500"/>
+              </a:spcAft>
+            </a:pPr>
+            <a:r>
+              <a:rPr sz="800" b="0" i="0">
+                <a:solidFill>
+                  <a:srgbClr val="5A6D80"/>
+                </a:solidFill>
+                <a:latin typeface="Segoe UI"/>
+              </a:rPr>
+              <a:t>Multi-agent portfolio research · Austin Agentic AI Hackathon · historical experiment, not financial advice</a:t>
+            </a:r>
+          </a:p>
+        </p:txBody>
+      </p:sp>
+      <p:sp>
+        <p:nvSpPr>
+          <p:cNvPr id="12" name="TextBox 11"/>
+          <p:cNvSpPr txBox="1"/>
+          <p:nvPr/>
+        </p:nvSpPr>
+        <p:spPr>
+          <a:xfrm>
+            <a:off x="11338560" y="6446520"/>
+            <a:ext cx="548640" cy="274320"/>
+          </a:xfrm>
+          <a:prstGeom prst="rect">
+            <a:avLst/>
+          </a:prstGeom>
+          <a:noFill/>
+        </p:spPr>
+        <p:txBody>
+          <a:bodyPr wrap="square" anchor="t">
+            <a:spAutoFit/>
+          </a:bodyPr>
+          <a:lstStyle/>
+          <a:p>
+            <a:pPr algn="r">
+              <a:spcAft>
+                <a:spcPts val="500"/>
+              </a:spcAft>
+            </a:pPr>
+            <a:r>
+              <a:rPr sz="900" b="0" i="0">
+                <a:solidFill>
+                  <a:srgbClr val="9FB0C0"/>
+                </a:solidFill>
+                <a:latin typeface="Segoe UI"/>
+              </a:rPr>
+              <a:t>3</a:t>
+            </a:r>
+          </a:p>
+        </p:txBody>
+      </p:sp>
+    </p:spTree>
+  </p:cSld>
+  <p:clrMapOvr>
+    <a:masterClrMapping/>
+  </p:clrMapOvr>
+</p:sld>
+</file>
+
+<file path=ppt/slides/slide4.xml><?xml version="1.0" encoding="utf-8"?>
+<p:sld xmlns:a="http://schemas.openxmlformats.org/drawingml/2006/main" xmlns:p="http://schemas.openxmlformats.org/presentationml/2006/main" xmlns:r="http://schemas.openxmlformats.org/officeDocument/2006/relationships">
+  <p:cSld>
+    <p:spTree>
+      <p:nvGrpSpPr>
+        <p:cNvPr id="1" name=""/>
+        <p:cNvGrpSpPr/>
+        <p:nvPr/>
+      </p:nvGrpSpPr>
+      <p:grpSpPr/>
+      <p:sp>
+        <p:nvSpPr>
+          <p:cNvPr id="2" name="Rectangle 1"/>
+          <p:cNvSpPr/>
+          <p:nvPr/>
+        </p:nvSpPr>
+        <p:spPr>
+          <a:xfrm>
+            <a:off x="0" y="0"/>
+            <a:ext cx="12191695" cy="6858000"/>
+          </a:xfrm>
+          <a:prstGeom prst="rect">
+            <a:avLst/>
+          </a:prstGeom>
+          <a:solidFill>
+            <a:srgbClr val="0A121F"/>
+          </a:solidFill>
+          <a:ln>
+            <a:noFill/>
+          </a:ln>
+          <a:effectLst/>
+        </p:spPr>
+        <p:style>
+          <a:lnRef idx="1">
+            <a:schemeClr val="accent1"/>
+          </a:lnRef>
+          <a:fillRef idx="3">
+            <a:schemeClr val="accent1"/>
+          </a:fillRef>
+          <a:effectRef idx="2">
+            <a:schemeClr val="accent1"/>
+          </a:effectRef>
+          <a:fontRef idx="minor">
+            <a:schemeClr val="lt1"/>
+          </a:fontRef>
+        </p:style>
+        <p:txBody>
+          <a:bodyPr rtlCol="0" anchor="ctr"/>
+          <a:lstStyle/>
+          <a:p>
+            <a:pPr algn="ctr"/>
+          </a:p>
+        </p:txBody>
+      </p:sp>
+      <p:sp>
+        <p:nvSpPr>
+          <p:cNvPr id="3" name="Rectangle 2"/>
+          <p:cNvSpPr/>
+          <p:nvPr/>
+        </p:nvSpPr>
+        <p:spPr>
+          <a:xfrm>
+            <a:off x="0" y="0"/>
+            <a:ext cx="109728" cy="6858000"/>
+          </a:xfrm>
+          <a:prstGeom prst="rect">
+            <a:avLst/>
+          </a:prstGeom>
+          <a:solidFill>
+            <a:srgbClr val="FF9900"/>
+          </a:solidFill>
+          <a:ln>
+            <a:noFill/>
+          </a:ln>
+          <a:effectLst/>
+        </p:spPr>
+        <p:style>
+          <a:lnRef idx="1">
+            <a:schemeClr val="accent1"/>
+          </a:lnRef>
+          <a:fillRef idx="3">
+            <a:schemeClr val="accent1"/>
+          </a:fillRef>
+          <a:effectRef idx="2">
+            <a:schemeClr val="accent1"/>
+          </a:effectRef>
+          <a:fontRef idx="minor">
+            <a:schemeClr val="lt1"/>
+          </a:fontRef>
+        </p:style>
+        <p:txBody>
+          <a:bodyPr rtlCol="0" anchor="ctr"/>
+          <a:lstStyle/>
+          <a:p>
+            <a:pPr algn="ctr"/>
+          </a:p>
+        </p:txBody>
+      </p:sp>
+      <p:sp>
+        <p:nvSpPr>
+          <p:cNvPr id="4" name="TextBox 3"/>
+          <p:cNvSpPr txBox="1"/>
+          <p:nvPr/>
+        </p:nvSpPr>
+        <p:spPr>
+          <a:xfrm>
+            <a:off x="502920" y="274320"/>
+            <a:ext cx="10058400" cy="365760"/>
+          </a:xfrm>
+          <a:prstGeom prst="rect">
+            <a:avLst/>
+          </a:prstGeom>
+          <a:noFill/>
+        </p:spPr>
+        <p:txBody>
+          <a:bodyPr wrap="square" anchor="t">
+            <a:spAutoFit/>
+          </a:bodyPr>
+          <a:lstStyle/>
+          <a:p>
+            <a:pPr algn="l">
+              <a:spcAft>
+                <a:spcPts val="500"/>
+              </a:spcAft>
+            </a:pPr>
+            <a:r>
+              <a:rPr sz="1200" b="1" i="0">
+                <a:solidFill>
+                  <a:srgbClr val="FF9900"/>
+                </a:solidFill>
+                <a:latin typeface="Segoe UI"/>
+              </a:rPr>
+              <a:t>WHAT HAPPENED</a:t>
+            </a:r>
+          </a:p>
+        </p:txBody>
+      </p:sp>
+      <p:sp>
+        <p:nvSpPr>
+          <p:cNvPr id="5" name="TextBox 4"/>
+          <p:cNvSpPr txBox="1"/>
+          <p:nvPr/>
+        </p:nvSpPr>
+        <p:spPr>
+          <a:xfrm>
+            <a:off x="502920" y="658368"/>
+            <a:ext cx="11155680" cy="731520"/>
+          </a:xfrm>
+          <a:prstGeom prst="rect">
+            <a:avLst/>
+          </a:prstGeom>
+          <a:noFill/>
+        </p:spPr>
+        <p:txBody>
+          <a:bodyPr wrap="square" anchor="t">
+            <a:spAutoFit/>
+          </a:bodyPr>
+          <a:lstStyle/>
+          <a:p>
+            <a:pPr algn="l">
+              <a:spcAft>
+                <a:spcPts val="500"/>
+              </a:spcAft>
+            </a:pPr>
+            <a:r>
+              <a:rPr sz="2900" b="1" i="0">
+                <a:solidFill>
+                  <a:srgbClr val="EAF1F8"/>
+                </a:solidFill>
+                <a:latin typeface="Segoe UI"/>
+              </a:rPr>
+              <a:t>Beats SPY on every measure; close to equal weight</a:t>
+            </a:r>
+          </a:p>
+        </p:txBody>
+      </p:sp>
+      <p:graphicFrame>
+        <p:nvGraphicFramePr>
+          <p:cNvPr id="6" name="Table 5"/>
+          <p:cNvGraphicFramePr>
+            <a:graphicFrameLocks noGrp="1"/>
+          </p:cNvGraphicFramePr>
+          <p:nvPr/>
+        </p:nvGraphicFramePr>
+        <p:xfrm>
+          <a:off x="502920" y="1417320"/>
+          <a:ext cx="6675120" cy="3291840"/>
+        </p:xfrm>
+        <a:graphic>
+          <a:graphicData uri="http://schemas.openxmlformats.org/drawingml/2006/table">
+            <a:tbl>
+              <a:tblPr firstRow="1" bandRow="1">
+                <a:tableStyleId>{5C22544A-7EE6-4342-B048-85BDC9FD1C3A}</a:tableStyleId>
+              </a:tblPr>
+              <a:tblGrid>
+                <a:gridCol w="2286000"/>
+                <a:gridCol w="1463040"/>
+                <a:gridCol w="1463040"/>
+                <a:gridCol w="1463040"/>
+              </a:tblGrid>
+              <a:tr h="548640">
+                <a:tc>
+                  <a:txBody>
+                    <a:bodyPr/>
+                    <a:lstStyle/>
+                    <a:p>
+                      <a:pPr algn="l"/>
+                      <a:r>
+                        <a:rPr sz="1200" b="1" i="0">
+                          <a:solidFill>
+                            <a:srgbClr val="EAF1F8"/>
+                          </a:solidFill>
+                          <a:latin typeface="Segoe UI"/>
+                        </a:rPr>
+                        <a:t>Metric</a:t>
+                      </a:r>
+                    </a:p>
+                  </a:txBody>
+                  <a:tcPr marT="25400" marB="25400" marL="88900" marR="88900" anchor="ctr">
+                    <a:solidFill>
+                      <a:srgbClr val="0F1B2D"/>
+                    </a:solidFill>
+                  </a:tcPr>
+                </a:tc>
+                <a:tc>
+                  <a:txBody>
+                    <a:bodyPr/>
+                    <a:lstStyle/>
+                    <a:p>
+                      <a:pPr algn="ctr"/>
+                      <a:r>
+                        <a:rPr sz="1200" b="1" i="0">
+                          <a:solidFill>
+                            <a:srgbClr val="EAF1F8"/>
+                          </a:solidFill>
+                          <a:latin typeface="Segoe UI"/>
+                        </a:rPr>
+                        <a:t>Portfolio</a:t>
+                      </a:r>
+                    </a:p>
+                  </a:txBody>
+                  <a:tcPr marT="25400" marB="25400" marL="88900" marR="88900" anchor="ctr">
+                    <a:solidFill>
+                      <a:srgbClr val="0F1B2D"/>
+                    </a:solidFill>
+                  </a:tcPr>
+                </a:tc>
+                <a:tc>
+                  <a:txBody>
+                    <a:bodyPr/>
+                    <a:lstStyle/>
+                    <a:p>
+                      <a:pPr algn="ctr"/>
+                      <a:r>
+                        <a:rPr sz="1200" b="1" i="0">
+                          <a:solidFill>
+                            <a:srgbClr val="EAF1F8"/>
+                          </a:solidFill>
+                          <a:latin typeface="Segoe UI"/>
+                        </a:rPr>
+                        <a:t>SPY</a:t>
+                      </a:r>
+                    </a:p>
+                  </a:txBody>
+                  <a:tcPr marT="25400" marB="25400" marL="88900" marR="88900" anchor="ctr">
+                    <a:solidFill>
+                      <a:srgbClr val="0F1B2D"/>
+                    </a:solidFill>
+                  </a:tcPr>
+                </a:tc>
+                <a:tc>
+                  <a:txBody>
+                    <a:bodyPr/>
+                    <a:lstStyle/>
+                    <a:p>
+                      <a:pPr algn="ctr"/>
+                      <a:r>
+                        <a:rPr sz="1200" b="1" i="0">
+                          <a:solidFill>
+                            <a:srgbClr val="EAF1F8"/>
+                          </a:solidFill>
+                          <a:latin typeface="Segoe UI"/>
+                        </a:rPr>
+                        <a:t>Equal wt</a:t>
+                      </a:r>
+                    </a:p>
+                  </a:txBody>
+                  <a:tcPr marT="25400" marB="25400" marL="88900" marR="88900" anchor="ctr">
+                    <a:solidFill>
+                      <a:srgbClr val="0F1B2D"/>
+                    </a:solidFill>
+                  </a:tcPr>
+                </a:tc>
+              </a:tr>
+              <a:tr h="548640">
+                <a:tc>
+                  <a:txBody>
+                    <a:bodyPr/>
+                    <a:lstStyle/>
+                    <a:p>
+                      <a:pPr algn="l"/>
+                      <a:r>
+                        <a:rPr sz="1200" b="0" i="0">
+                          <a:solidFill>
+                            <a:srgbClr val="EAF1F8"/>
+                          </a:solidFill>
+                          <a:latin typeface="Segoe UI"/>
+                        </a:rPr>
+                        <a:t>Total return</a:t>
+                      </a:r>
+                    </a:p>
+                  </a:txBody>
+                  <a:tcPr marT="25400" marB="25400" marL="88900" marR="88900" anchor="ctr">
+                    <a:solidFill>
+                      <a:srgbClr val="142438"/>
+                    </a:solidFill>
+                  </a:tcPr>
+                </a:tc>
+                <a:tc>
+                  <a:txBody>
+                    <a:bodyPr/>
+                    <a:lstStyle/>
+                    <a:p>
+                      <a:pPr algn="ctr"/>
+                      <a:r>
+                        <a:rPr sz="1200" b="0" i="0">
+                          <a:solidFill>
+                            <a:srgbClr val="1C8A5E"/>
+                          </a:solidFill>
+                          <a:latin typeface="Segoe UI"/>
+                        </a:rPr>
+                        <a:t>16.7%</a:t>
+                      </a:r>
+                    </a:p>
+                  </a:txBody>
+                  <a:tcPr marT="25400" marB="25400" marL="88900" marR="88900" anchor="ctr">
+                    <a:solidFill>
+                      <a:srgbClr val="142438"/>
+                    </a:solidFill>
+                  </a:tcPr>
+                </a:tc>
+                <a:tc>
+                  <a:txBody>
+                    <a:bodyPr/>
+                    <a:lstStyle/>
+                    <a:p>
+                      <a:pPr algn="ctr"/>
+                      <a:r>
+                        <a:rPr sz="1200" b="0" i="0">
+                          <a:solidFill>
+                            <a:srgbClr val="EAF1F8"/>
+                          </a:solidFill>
+                          <a:latin typeface="Segoe UI"/>
+                        </a:rPr>
+                        <a:t>11.2%</a:t>
+                      </a:r>
+                    </a:p>
+                  </a:txBody>
+                  <a:tcPr marT="25400" marB="25400" marL="88900" marR="88900" anchor="ctr">
+                    <a:solidFill>
+                      <a:srgbClr val="142438"/>
+                    </a:solidFill>
+                  </a:tcPr>
+                </a:tc>
+                <a:tc>
+                  <a:txBody>
+                    <a:bodyPr/>
+                    <a:lstStyle/>
+                    <a:p>
+                      <a:pPr algn="ctr"/>
+                      <a:r>
+                        <a:rPr sz="1200" b="0" i="0">
+                          <a:solidFill>
+                            <a:srgbClr val="EAF1F8"/>
+                          </a:solidFill>
+                          <a:latin typeface="Segoe UI"/>
+                        </a:rPr>
+                        <a:t>15.5%</a:t>
+                      </a:r>
+                    </a:p>
+                  </a:txBody>
+                  <a:tcPr marT="25400" marB="25400" marL="88900" marR="88900" anchor="ctr">
+                    <a:solidFill>
+                      <a:srgbClr val="142438"/>
+                    </a:solidFill>
+                  </a:tcPr>
+                </a:tc>
+              </a:tr>
+              <a:tr h="548640">
+                <a:tc>
+                  <a:txBody>
+                    <a:bodyPr/>
+                    <a:lstStyle/>
+                    <a:p>
+                      <a:pPr algn="l"/>
+                      <a:r>
+                        <a:rPr sz="1200" b="0" i="0">
+                          <a:solidFill>
+                            <a:srgbClr val="EAF1F8"/>
+                          </a:solidFill>
+                          <a:latin typeface="Segoe UI"/>
+                        </a:rPr>
+                        <a:t>CAGR</a:t>
+                      </a:r>
+                    </a:p>
+                  </a:txBody>
+                  <a:tcPr marT="25400" marB="25400" marL="88900" marR="88900" anchor="ctr">
+                    <a:solidFill>
+                      <a:srgbClr val="142438"/>
+                    </a:solidFill>
+                  </a:tcPr>
+                </a:tc>
+                <a:tc>
+                  <a:txBody>
+                    <a:bodyPr/>
+                    <a:lstStyle/>
+                    <a:p>
+                      <a:pPr algn="ctr"/>
+                      <a:r>
+                        <a:rPr sz="1200" b="0" i="0">
+                          <a:solidFill>
+                            <a:srgbClr val="1C8A5E"/>
+                          </a:solidFill>
+                          <a:latin typeface="Segoe UI"/>
+                        </a:rPr>
+                        <a:t>24.3%</a:t>
+                      </a:r>
+                    </a:p>
+                  </a:txBody>
+                  <a:tcPr marT="25400" marB="25400" marL="88900" marR="88900" anchor="ctr">
+                    <a:solidFill>
+                      <a:srgbClr val="142438"/>
+                    </a:solidFill>
+                  </a:tcPr>
+                </a:tc>
+                <a:tc>
+                  <a:txBody>
+                    <a:bodyPr/>
+                    <a:lstStyle/>
+                    <a:p>
+                      <a:pPr algn="ctr"/>
+                      <a:r>
+                        <a:rPr sz="1200" b="0" i="0">
+                          <a:solidFill>
+                            <a:srgbClr val="EAF1F8"/>
+                          </a:solidFill>
+                          <a:latin typeface="Segoe UI"/>
+                        </a:rPr>
+                        <a:t>16.1%</a:t>
+                      </a:r>
+                    </a:p>
+                  </a:txBody>
+                  <a:tcPr marT="25400" marB="25400" marL="88900" marR="88900" anchor="ctr">
+                    <a:solidFill>
+                      <a:srgbClr val="142438"/>
+                    </a:solidFill>
+                  </a:tcPr>
+                </a:tc>
+                <a:tc>
+                  <a:txBody>
+                    <a:bodyPr/>
+                    <a:lstStyle/>
+                    <a:p>
+                      <a:pPr algn="ctr"/>
+                      <a:r>
+                        <a:rPr sz="1200" b="0" i="0">
+                          <a:solidFill>
+                            <a:srgbClr val="EAF1F8"/>
+                          </a:solidFill>
+                          <a:latin typeface="Segoe UI"/>
+                        </a:rPr>
+                        <a:t>22.6%</a:t>
+                      </a:r>
+                    </a:p>
+                  </a:txBody>
+                  <a:tcPr marT="25400" marB="25400" marL="88900" marR="88900" anchor="ctr">
+                    <a:solidFill>
+                      <a:srgbClr val="142438"/>
+                    </a:solidFill>
+                  </a:tcPr>
+                </a:tc>
+              </a:tr>
+              <a:tr h="548640">
+                <a:tc>
+                  <a:txBody>
+                    <a:bodyPr/>
+                    <a:lstStyle/>
+                    <a:p>
+                      <a:pPr algn="l"/>
+                      <a:r>
+                        <a:rPr sz="1200" b="0" i="0">
+                          <a:solidFill>
+                            <a:srgbClr val="EAF1F8"/>
+                          </a:solidFill>
+                          <a:latin typeface="Segoe UI"/>
+                        </a:rPr>
+                        <a:t>Volatility</a:t>
+                      </a:r>
+                    </a:p>
+                  </a:txBody>
+                  <a:tcPr marT="25400" marB="25400" marL="88900" marR="88900" anchor="ctr">
+                    <a:solidFill>
+                      <a:srgbClr val="142438"/>
+                    </a:solidFill>
+                  </a:tcPr>
+                </a:tc>
+                <a:tc>
+                  <a:txBody>
+                    <a:bodyPr/>
+                    <a:lstStyle/>
+                    <a:p>
+                      <a:pPr algn="ctr"/>
+                      <a:r>
+                        <a:rPr sz="1200" b="0" i="0">
+                          <a:solidFill>
+                            <a:srgbClr val="1C8A5E"/>
+                          </a:solidFill>
+                          <a:latin typeface="Segoe UI"/>
+                        </a:rPr>
+                        <a:t>9.4%</a:t>
+                      </a:r>
+                    </a:p>
+                  </a:txBody>
+                  <a:tcPr marT="25400" marB="25400" marL="88900" marR="88900" anchor="ctr">
+                    <a:solidFill>
+                      <a:srgbClr val="142438"/>
+                    </a:solidFill>
+                  </a:tcPr>
+                </a:tc>
+                <a:tc>
+                  <a:txBody>
+                    <a:bodyPr/>
+                    <a:lstStyle/>
+                    <a:p>
+                      <a:pPr algn="ctr"/>
+                      <a:r>
+                        <a:rPr sz="1200" b="0" i="0">
+                          <a:solidFill>
+                            <a:srgbClr val="EAF1F8"/>
+                          </a:solidFill>
+                          <a:latin typeface="Segoe UI"/>
+                        </a:rPr>
+                        <a:t>13.3%</a:t>
+                      </a:r>
+                    </a:p>
+                  </a:txBody>
+                  <a:tcPr marT="25400" marB="25400" marL="88900" marR="88900" anchor="ctr">
+                    <a:solidFill>
+                      <a:srgbClr val="142438"/>
+                    </a:solidFill>
+                  </a:tcPr>
+                </a:tc>
+                <a:tc>
+                  <a:txBody>
+                    <a:bodyPr/>
+                    <a:lstStyle/>
+                    <a:p>
+                      <a:pPr algn="ctr"/>
+                      <a:r>
+                        <a:rPr sz="1200" b="0" i="0">
+                          <a:solidFill>
+                            <a:srgbClr val="EAF1F8"/>
+                          </a:solidFill>
+                          <a:latin typeface="Segoe UI"/>
+                        </a:rPr>
+                        <a:t>10.3%</a:t>
+                      </a:r>
+                    </a:p>
+                  </a:txBody>
+                  <a:tcPr marT="25400" marB="25400" marL="88900" marR="88900" anchor="ctr">
+                    <a:solidFill>
+                      <a:srgbClr val="142438"/>
+                    </a:solidFill>
+                  </a:tcPr>
+                </a:tc>
+              </a:tr>
+              <a:tr h="548640">
+                <a:tc>
+                  <a:txBody>
+                    <a:bodyPr/>
+                    <a:lstStyle/>
+                    <a:p>
+                      <a:pPr algn="l"/>
+                      <a:r>
+                        <a:rPr sz="1200" b="0" i="0">
+                          <a:solidFill>
+                            <a:srgbClr val="EAF1F8"/>
+                          </a:solidFill>
+                          <a:latin typeface="Segoe UI"/>
+                        </a:rPr>
+                        <a:t>Sharpe</a:t>
+                      </a:r>
+                    </a:p>
+                  </a:txBody>
+                  <a:tcPr marT="25400" marB="25400" marL="88900" marR="88900" anchor="ctr">
+                    <a:solidFill>
+                      <a:srgbClr val="142438"/>
+                    </a:solidFill>
+                  </a:tcPr>
+                </a:tc>
+                <a:tc>
+                  <a:txBody>
+                    <a:bodyPr/>
+                    <a:lstStyle/>
+                    <a:p>
+                      <a:pPr algn="ctr"/>
+                      <a:r>
+                        <a:rPr sz="1200" b="0" i="0">
+                          <a:solidFill>
+                            <a:srgbClr val="1C8A5E"/>
+                          </a:solidFill>
+                          <a:latin typeface="Segoe UI"/>
+                        </a:rPr>
+                        <a:t>2.37</a:t>
+                      </a:r>
+                    </a:p>
+                  </a:txBody>
+                  <a:tcPr marT="25400" marB="25400" marL="88900" marR="88900" anchor="ctr">
+                    <a:solidFill>
+                      <a:srgbClr val="142438"/>
+                    </a:solidFill>
+                  </a:tcPr>
+                </a:tc>
+                <a:tc>
+                  <a:txBody>
+                    <a:bodyPr/>
+                    <a:lstStyle/>
+                    <a:p>
+                      <a:pPr algn="ctr"/>
+                      <a:r>
+                        <a:rPr sz="1200" b="0" i="0">
+                          <a:solidFill>
+                            <a:srgbClr val="EAF1F8"/>
+                          </a:solidFill>
+                          <a:latin typeface="Segoe UI"/>
+                        </a:rPr>
+                        <a:t>1.19</a:t>
+                      </a:r>
+                    </a:p>
+                  </a:txBody>
+                  <a:tcPr marT="25400" marB="25400" marL="88900" marR="88900" anchor="ctr">
+                    <a:solidFill>
+                      <a:srgbClr val="142438"/>
+                    </a:solidFill>
+                  </a:tcPr>
+                </a:tc>
+                <a:tc>
+                  <a:txBody>
+                    <a:bodyPr/>
+                    <a:lstStyle/>
+                    <a:p>
+                      <a:pPr algn="ctr"/>
+                      <a:r>
+                        <a:rPr sz="1200" b="0" i="0">
+                          <a:solidFill>
+                            <a:srgbClr val="EAF1F8"/>
+                          </a:solidFill>
+                          <a:latin typeface="Segoe UI"/>
+                        </a:rPr>
+                        <a:t>2.02</a:t>
+                      </a:r>
+                    </a:p>
+                  </a:txBody>
+                  <a:tcPr marT="25400" marB="25400" marL="88900" marR="88900" anchor="ctr">
+                    <a:solidFill>
+                      <a:srgbClr val="142438"/>
+                    </a:solidFill>
+                  </a:tcPr>
+                </a:tc>
+              </a:tr>
+              <a:tr h="548640">
+                <a:tc>
+                  <a:txBody>
+                    <a:bodyPr/>
+                    <a:lstStyle/>
+                    <a:p>
+                      <a:pPr algn="l"/>
+                      <a:r>
+                        <a:rPr sz="1200" b="0" i="0">
+                          <a:solidFill>
+                            <a:srgbClr val="EAF1F8"/>
+                          </a:solidFill>
+                          <a:latin typeface="Segoe UI"/>
+                        </a:rPr>
+                        <a:t>Max drawdown</a:t>
+                      </a:r>
+                    </a:p>
+                  </a:txBody>
+                  <a:tcPr marT="25400" marB="25400" marL="88900" marR="88900" anchor="ctr">
+                    <a:solidFill>
+                      <a:srgbClr val="142438"/>
+                    </a:solidFill>
+                  </a:tcPr>
+                </a:tc>
+                <a:tc>
+                  <a:txBody>
+                    <a:bodyPr/>
+                    <a:lstStyle/>
+                    <a:p>
+                      <a:pPr algn="ctr"/>
+                      <a:r>
+                        <a:rPr sz="1200" b="0" i="0">
+                          <a:solidFill>
+                            <a:srgbClr val="1C8A5E"/>
+                          </a:solidFill>
+                          <a:latin typeface="Segoe UI"/>
+                        </a:rPr>
+                        <a:t>-5.3%</a:t>
+                      </a:r>
+                    </a:p>
+                  </a:txBody>
+                  <a:tcPr marT="25400" marB="25400" marL="88900" marR="88900" anchor="ctr">
+                    <a:solidFill>
+                      <a:srgbClr val="142438"/>
+                    </a:solidFill>
+                  </a:tcPr>
+                </a:tc>
+                <a:tc>
+                  <a:txBody>
+                    <a:bodyPr/>
+                    <a:lstStyle/>
+                    <a:p>
+                      <a:pPr algn="ctr"/>
+                      <a:r>
+                        <a:rPr sz="1200" b="0" i="0">
+                          <a:solidFill>
+                            <a:srgbClr val="EAF1F8"/>
+                          </a:solidFill>
+                          <a:latin typeface="Segoe UI"/>
+                        </a:rPr>
+                        <a:t>-8.9%</a:t>
+                      </a:r>
+                    </a:p>
+                  </a:txBody>
+                  <a:tcPr marT="25400" marB="25400" marL="88900" marR="88900" anchor="ctr">
+                    <a:solidFill>
+                      <a:srgbClr val="142438"/>
+                    </a:solidFill>
+                  </a:tcPr>
+                </a:tc>
+                <a:tc>
+                  <a:txBody>
+                    <a:bodyPr/>
+                    <a:lstStyle/>
+                    <a:p>
+                      <a:pPr algn="ctr"/>
+                      <a:r>
+                        <a:rPr sz="1200" b="0" i="0">
+                          <a:solidFill>
+                            <a:srgbClr val="EAF1F8"/>
+                          </a:solidFill>
+                          <a:latin typeface="Segoe UI"/>
+                        </a:rPr>
+                        <a:t>-6.1%</a:t>
+                      </a:r>
+                    </a:p>
+                  </a:txBody>
+                  <a:tcPr marT="25400" marB="25400" marL="88900" marR="88900" anchor="ctr">
+                    <a:solidFill>
+                      <a:srgbClr val="142438"/>
+                    </a:solidFill>
+                  </a:tcPr>
+                </a:tc>
+              </a:tr>
+            </a:tbl>
+          </a:graphicData>
+        </a:graphic>
+      </p:graphicFrame>
+      <p:sp>
+        <p:nvSpPr>
+          <p:cNvPr id="7" name="Rounded Rectangle 6"/>
+          <p:cNvSpPr/>
+          <p:nvPr/>
+        </p:nvSpPr>
+        <p:spPr>
+          <a:xfrm>
+            <a:off x="7406640" y="1417320"/>
+            <a:ext cx="4251960" cy="3291840"/>
+          </a:xfrm>
+          <a:prstGeom prst="roundRect">
+            <a:avLst>
+              <a:gd name="adj" fmla="val 5000"/>
+            </a:avLst>
+          </a:prstGeom>
+          <a:solidFill>
+            <a:srgbClr val="142438"/>
+          </a:solidFill>
+          <a:ln w="25400">
+            <a:solidFill>
+              <a:srgbClr val="EC7111"/>
+            </a:solidFill>
+          </a:ln>
+          <a:effectLst/>
+        </p:spPr>
+        <p:style>
+          <a:lnRef idx="1">
+            <a:schemeClr val="accent1"/>
+          </a:lnRef>
+          <a:fillRef idx="3">
+            <a:schemeClr val="accent1"/>
+          </a:fillRef>
+          <a:effectRef idx="2">
+            <a:schemeClr val="accent1"/>
+          </a:effectRef>
+          <a:fontRef idx="minor">
+            <a:schemeClr val="lt1"/>
+          </a:fontRef>
+        </p:style>
+        <p:txBody>
+          <a:bodyPr rtlCol="0" anchor="ctr"/>
+          <a:lstStyle/>
+          <a:p>
+            <a:pPr algn="ctr"/>
+          </a:p>
+        </p:txBody>
+      </p:sp>
+      <p:sp>
+        <p:nvSpPr>
+          <p:cNvPr id="8" name="TextBox 7"/>
+          <p:cNvSpPr txBox="1"/>
+          <p:nvPr/>
+        </p:nvSpPr>
+        <p:spPr>
+          <a:xfrm>
+            <a:off x="7589520" y="1536192"/>
+            <a:ext cx="3931920" cy="3108960"/>
+          </a:xfrm>
+          <a:prstGeom prst="rect">
+            <a:avLst/>
+          </a:prstGeom>
+          <a:noFill/>
+        </p:spPr>
+        <p:txBody>
+          <a:bodyPr wrap="square" anchor="t">
+            <a:spAutoFit/>
+          </a:bodyPr>
+          <a:lstStyle/>
+          <a:p>
+            <a:pPr algn="l">
+              <a:lnSpc>
+                <a:spcPct val="107000"/>
+              </a:lnSpc>
+              <a:spcAft>
+                <a:spcPts val="700"/>
+              </a:spcAft>
+            </a:pPr>
+            <a:r>
+              <a:rPr sz="1450" b="1" i="0">
+                <a:solidFill>
+                  <a:srgbClr val="EAF1F8"/>
+                </a:solidFill>
+                <a:latin typeface="Segoe UI"/>
+              </a:rPr>
+              <a:t>How stable is this?</a:t>
+            </a:r>
+          </a:p>
+          <a:p>
+            <a:pPr algn="l">
+              <a:lnSpc>
+                <a:spcPct val="107000"/>
+              </a:lnSpc>
+              <a:spcAft>
+                <a:spcPts val="700"/>
+              </a:spcAft>
+            </a:pPr>
+            <a:r>
+              <a:rPr sz="1150" b="0" i="0">
+                <a:solidFill>
+                  <a:srgbClr val="9FB0C0"/>
+                </a:solidFill>
+                <a:latin typeface="Segoe UI"/>
+              </a:rPr>
+              <a:t>The models take no temperature setting, so uncached runs vary. Across five uncached runs on identical evidence:</a:t>
+            </a:r>
+          </a:p>
+          <a:p>
+            <a:pPr algn="l">
+              <a:lnSpc>
+                <a:spcPct val="107000"/>
+              </a:lnSpc>
+              <a:spcAft>
+                <a:spcPts val="700"/>
+              </a:spcAft>
+            </a:pPr>
+            <a:r>
+              <a:rPr sz="1250" b="1" i="0">
+                <a:solidFill>
+                  <a:srgbClr val="EAF1F8"/>
+                </a:solidFill>
+                <a:latin typeface="Segoe UI"/>
+              </a:rPr>
+              <a:t>Return 15.7% mean, range 14.9–16.4%.</a:t>
+            </a:r>
+          </a:p>
+          <a:p>
+            <a:pPr algn="l">
+              <a:lnSpc>
+                <a:spcPct val="107000"/>
+              </a:lnSpc>
+              <a:spcAft>
+                <a:spcPts val="700"/>
+              </a:spcAft>
+            </a:pPr>
+            <a:r>
+              <a:rPr sz="1200" b="0" i="0">
+                <a:solidFill>
+                  <a:srgbClr val="9FB0C0"/>
+                </a:solidFill>
+                <a:latin typeface="Segoe UI"/>
+              </a:rPr>
+              <a:t>Beat SPY in </a:t>
+            </a:r>
+            <a:r>
+              <a:rPr sz="1300" b="1" i="0">
+                <a:solidFill>
+                  <a:srgbClr val="1C8A5E"/>
+                </a:solidFill>
+                <a:latin typeface="Segoe UI"/>
+              </a:rPr>
+              <a:t>5 of 5</a:t>
+            </a:r>
+            <a:r>
+              <a:rPr sz="1200" b="0" i="0">
+                <a:solidFill>
+                  <a:srgbClr val="9FB0C0"/>
+                </a:solidFill>
+                <a:latin typeface="Segoe UI"/>
+              </a:rPr>
+              <a:t> runs; beat equal weight in </a:t>
+            </a:r>
+            <a:r>
+              <a:rPr sz="1300" b="1" i="0">
+                <a:solidFill>
+                  <a:srgbClr val="FF9900"/>
+                </a:solidFill>
+                <a:latin typeface="Segoe UI"/>
+              </a:rPr>
+              <a:t>3 of 5</a:t>
+            </a:r>
+            <a:r>
+              <a:rPr sz="1200" b="0" i="0">
+                <a:solidFill>
+                  <a:srgbClr val="9FB0C0"/>
+                </a:solidFill>
+                <a:latin typeface="Segoe UI"/>
+              </a:rPr>
+              <a:t>.</a:t>
+            </a:r>
+          </a:p>
+          <a:p>
+            <a:pPr algn="l">
+              <a:lnSpc>
+                <a:spcPct val="107000"/>
+              </a:lnSpc>
+              <a:spcAft>
+                <a:spcPts val="700"/>
+              </a:spcAft>
+            </a:pPr>
+            <a:r>
+              <a:rPr sz="1100" b="0" i="1">
+                <a:solidFill>
+                  <a:srgbClr val="9FB0C0"/>
+                </a:solidFill>
+                <a:latin typeface="Segoe UI"/>
+              </a:rPr>
+              <a:t>Read honestly: reliably beats SPY, statistically close to equal weight. The frozen run is one draw, kept so the demo reproduces.</a:t>
+            </a:r>
+          </a:p>
+        </p:txBody>
+      </p:sp>
+      <p:sp>
+        <p:nvSpPr>
+          <p:cNvPr id="9" name="TextBox 8"/>
+          <p:cNvSpPr txBox="1"/>
+          <p:nvPr/>
+        </p:nvSpPr>
+        <p:spPr>
+          <a:xfrm>
+            <a:off x="502920" y="4937760"/>
+            <a:ext cx="11155680" cy="914400"/>
+          </a:xfrm>
+          <a:prstGeom prst="rect">
+            <a:avLst/>
+          </a:prstGeom>
+          <a:noFill/>
+        </p:spPr>
+        <p:txBody>
+          <a:bodyPr wrap="square" anchor="t">
+            <a:spAutoFit/>
+          </a:bodyPr>
+          <a:lstStyle/>
+          <a:p>
+            <a:pPr algn="l">
+              <a:lnSpc>
+                <a:spcPct val="110000"/>
+              </a:lnSpc>
+              <a:spcAft>
+                <a:spcPts val="500"/>
+              </a:spcAft>
+            </a:pPr>
+            <a:r>
+              <a:rPr sz="1300" b="1" i="0">
+                <a:solidFill>
+                  <a:srgbClr val="EAF1F8"/>
+                </a:solidFill>
+                <a:latin typeface="Segoe UI"/>
+              </a:rPr>
+              <a:t>Top contributors: </a:t>
+            </a:r>
+            <a:r>
+              <a:rPr sz="1300" b="0" i="0">
+                <a:solidFill>
+                  <a:srgbClr val="9FB0C0"/>
+                </a:solidFill>
+                <a:latin typeface="Segoe UI"/>
+              </a:rPr>
+              <a:t>AAPL +4.6 pts, XOM +3.5, KO +2.8; only NEE detracted. Beating the market was never the goal — a traceable thesis and an honest test are, and we report the result either way.</a:t>
+            </a:r>
+          </a:p>
+        </p:txBody>
+      </p:sp>
+      <p:sp>
+        <p:nvSpPr>
+          <p:cNvPr id="10" name="TextBox 9"/>
+          <p:cNvSpPr txBox="1"/>
+          <p:nvPr/>
+        </p:nvSpPr>
+        <p:spPr>
+          <a:xfrm>
+            <a:off x="502920" y="6446520"/>
+            <a:ext cx="9144000" cy="274320"/>
+          </a:xfrm>
+          <a:prstGeom prst="rect">
+            <a:avLst/>
+          </a:prstGeom>
+          <a:noFill/>
+        </p:spPr>
+        <p:txBody>
+          <a:bodyPr wrap="square" anchor="t">
+            <a:spAutoFit/>
+          </a:bodyPr>
+          <a:lstStyle/>
+          <a:p>
+            <a:pPr algn="l">
+              <a:spcAft>
+                <a:spcPts val="500"/>
+              </a:spcAft>
+            </a:pPr>
+            <a:r>
+              <a:rPr sz="800" b="0" i="0">
+                <a:solidFill>
+                  <a:srgbClr val="5A6D80"/>
+                </a:solidFill>
+                <a:latin typeface="Segoe UI"/>
+              </a:rPr>
+              <a:t>Multi-agent portfolio research · Austin Agentic AI Hackathon · historical experiment, not financial advice</a:t>
+            </a:r>
+          </a:p>
+        </p:txBody>
+      </p:sp>
+      <p:sp>
+        <p:nvSpPr>
+          <p:cNvPr id="11" name="TextBox 10"/>
+          <p:cNvSpPr txBox="1"/>
+          <p:nvPr/>
+        </p:nvSpPr>
+        <p:spPr>
+          <a:xfrm>
+            <a:off x="11338560" y="6446520"/>
+            <a:ext cx="548640" cy="274320"/>
+          </a:xfrm>
+          <a:prstGeom prst="rect">
+            <a:avLst/>
+          </a:prstGeom>
+          <a:noFill/>
+        </p:spPr>
+        <p:txBody>
+          <a:bodyPr wrap="square" anchor="t">
+            <a:spAutoFit/>
+          </a:bodyPr>
+          <a:lstStyle/>
+          <a:p>
+            <a:pPr algn="r">
+              <a:spcAft>
+                <a:spcPts val="500"/>
+              </a:spcAft>
+            </a:pPr>
+            <a:r>
+              <a:rPr sz="900" b="0" i="0">
+                <a:solidFill>
+                  <a:srgbClr val="9FB0C0"/>
+                </a:solidFill>
+                <a:latin typeface="Segoe UI"/>
+              </a:rPr>
+              <a:t>4</a:t>
+            </a:r>
+          </a:p>
+        </p:txBody>
+      </p:sp>
+    </p:spTree>
+  </p:cSld>
+  <p:clrMapOvr>
+    <a:masterClrMapping/>
+  </p:clrMapOvr>
+</p:sld>
+</file>
+
+<file path=ppt/slides/slide5.xml><?xml version="1.0" encoding="utf-8"?>
+<p:sld xmlns:a="http://schemas.openxmlformats.org/drawingml/2006/main" xmlns:p="http://schemas.openxmlformats.org/presentationml/2006/main" xmlns:r="http://schemas.openxmlformats.org/officeDocument/2006/relationships">
+  <p:cSld>
+    <p:spTree>
+      <p:nvGrpSpPr>
+        <p:cNvPr id="1" name=""/>
+        <p:cNvGrpSpPr/>
+        <p:nvPr/>
+      </p:nvGrpSpPr>
+      <p:grpSpPr/>
+      <p:sp>
+        <p:nvSpPr>
+          <p:cNvPr id="2" name="Rectangle 1"/>
+          <p:cNvSpPr/>
+          <p:nvPr/>
+        </p:nvSpPr>
+        <p:spPr>
+          <a:xfrm>
+            <a:off x="0" y="0"/>
+            <a:ext cx="12191695" cy="6858000"/>
+          </a:xfrm>
+          <a:prstGeom prst="rect">
+            <a:avLst/>
+          </a:prstGeom>
+          <a:solidFill>
+            <a:srgbClr val="0A121F"/>
+          </a:solidFill>
+          <a:ln>
+            <a:noFill/>
+          </a:ln>
+          <a:effectLst/>
+        </p:spPr>
+        <p:style>
+          <a:lnRef idx="1">
+            <a:schemeClr val="accent1"/>
+          </a:lnRef>
+          <a:fillRef idx="3">
+            <a:schemeClr val="accent1"/>
+          </a:fillRef>
+          <a:effectRef idx="2">
+            <a:schemeClr val="accent1"/>
+          </a:effectRef>
+          <a:fontRef idx="minor">
+            <a:schemeClr val="lt1"/>
+          </a:fontRef>
+        </p:style>
+        <p:txBody>
+          <a:bodyPr rtlCol="0" anchor="ctr"/>
+          <a:lstStyle/>
+          <a:p>
+            <a:pPr algn="ctr"/>
+          </a:p>
+        </p:txBody>
+      </p:sp>
+      <p:sp>
+        <p:nvSpPr>
+          <p:cNvPr id="3" name="Rectangle 2"/>
+          <p:cNvSpPr/>
+          <p:nvPr/>
+        </p:nvSpPr>
+        <p:spPr>
+          <a:xfrm>
+            <a:off x="0" y="0"/>
+            <a:ext cx="109728" cy="6858000"/>
+          </a:xfrm>
+          <a:prstGeom prst="rect">
+            <a:avLst/>
+          </a:prstGeom>
+          <a:solidFill>
+            <a:srgbClr val="FF9900"/>
+          </a:solidFill>
+          <a:ln>
+            <a:noFill/>
+          </a:ln>
+          <a:effectLst/>
+        </p:spPr>
+        <p:style>
+          <a:lnRef idx="1">
+            <a:schemeClr val="accent1"/>
+          </a:lnRef>
+          <a:fillRef idx="3">
+            <a:schemeClr val="accent1"/>
+          </a:fillRef>
+          <a:effectRef idx="2">
+            <a:schemeClr val="accent1"/>
+          </a:effectRef>
+          <a:fontRef idx="minor">
+            <a:schemeClr val="lt1"/>
+          </a:fontRef>
+        </p:style>
+        <p:txBody>
+          <a:bodyPr rtlCol="0" anchor="ctr"/>
+          <a:lstStyle/>
+          <a:p>
+            <a:pPr algn="ctr"/>
+          </a:p>
+        </p:txBody>
+      </p:sp>
+      <p:sp>
+        <p:nvSpPr>
+          <p:cNvPr id="4" name="TextBox 3"/>
+          <p:cNvSpPr txBox="1"/>
+          <p:nvPr/>
+        </p:nvSpPr>
+        <p:spPr>
+          <a:xfrm>
+            <a:off x="502920" y="274320"/>
+            <a:ext cx="10058400" cy="365760"/>
+          </a:xfrm>
+          <a:prstGeom prst="rect">
+            <a:avLst/>
+          </a:prstGeom>
+          <a:noFill/>
+        </p:spPr>
+        <p:txBody>
+          <a:bodyPr wrap="square" anchor="t">
+            <a:spAutoFit/>
+          </a:bodyPr>
+          <a:lstStyle/>
+          <a:p>
+            <a:pPr algn="l">
+              <a:spcAft>
+                <a:spcPts val="500"/>
+              </a:spcAft>
+            </a:pPr>
+            <a:r>
+              <a:rPr sz="1200" b="1" i="0">
+                <a:solidFill>
+                  <a:srgbClr val="FF9900"/>
+                </a:solidFill>
+                <a:latin typeface="Segoe UI"/>
+              </a:rPr>
+              <a:t>CREDIBILITY &amp; WHAT'S NEXT</a:t>
+            </a:r>
+          </a:p>
+        </p:txBody>
+      </p:sp>
+      <p:sp>
+        <p:nvSpPr>
+          <p:cNvPr id="5" name="TextBox 4"/>
+          <p:cNvSpPr txBox="1"/>
+          <p:nvPr/>
+        </p:nvSpPr>
+        <p:spPr>
+          <a:xfrm>
+            <a:off x="502920" y="658368"/>
+            <a:ext cx="11155680" cy="731520"/>
+          </a:xfrm>
+          <a:prstGeom prst="rect">
+            <a:avLst/>
+          </a:prstGeom>
+          <a:noFill/>
+        </p:spPr>
+        <p:txBody>
+          <a:bodyPr wrap="square" anchor="t">
+            <a:spAutoFit/>
+          </a:bodyPr>
+          <a:lstStyle/>
+          <a:p>
+            <a:pPr algn="l">
+              <a:spcAft>
+                <a:spcPts val="500"/>
+              </a:spcAft>
+            </a:pPr>
+            <a:r>
+              <a:rPr sz="2900" b="1" i="0">
+                <a:solidFill>
+                  <a:srgbClr val="EAF1F8"/>
+                </a:solidFill>
+                <a:latin typeface="Segoe UI"/>
+              </a:rPr>
+              <a:t>Stress-tested, self-checking, and honest about limits</a:t>
+            </a:r>
+          </a:p>
+        </p:txBody>
+      </p:sp>
+      <p:sp>
+        <p:nvSpPr>
+          <p:cNvPr id="6" name="Rounded Rectangle 5"/>
+          <p:cNvSpPr/>
+          <p:nvPr/>
+        </p:nvSpPr>
+        <p:spPr>
+          <a:xfrm>
+            <a:off x="502920" y="1371600"/>
+            <a:ext cx="5486400" cy="4160520"/>
+          </a:xfrm>
+          <a:prstGeom prst="roundRect">
+            <a:avLst>
+              <a:gd name="adj" fmla="val 5000"/>
+            </a:avLst>
+          </a:prstGeom>
+          <a:solidFill>
+            <a:srgbClr val="142438"/>
+          </a:solidFill>
+          <a:ln w="25400">
+            <a:solidFill>
+              <a:srgbClr val="1C8A5E"/>
+            </a:solidFill>
+          </a:ln>
+          <a:effectLst/>
+        </p:spPr>
+        <p:style>
+          <a:lnRef idx="1">
+            <a:schemeClr val="accent1"/>
+          </a:lnRef>
+          <a:fillRef idx="3">
+            <a:schemeClr val="accent1"/>
+          </a:fillRef>
+          <a:effectRef idx="2">
+            <a:schemeClr val="accent1"/>
+          </a:effectRef>
+          <a:fontRef idx="minor">
+            <a:schemeClr val="lt1"/>
+          </a:fontRef>
+        </p:style>
+        <p:txBody>
+          <a:bodyPr rtlCol="0" anchor="ctr"/>
+          <a:lstStyle/>
+          <a:p>
+            <a:pPr algn="ctr"/>
+          </a:p>
+        </p:txBody>
+      </p:sp>
+      <p:sp>
+        <p:nvSpPr>
+          <p:cNvPr id="7" name="TextBox 6"/>
+          <p:cNvSpPr txBox="1"/>
+          <p:nvPr/>
+        </p:nvSpPr>
+        <p:spPr>
+          <a:xfrm>
+            <a:off x="731520" y="1481328"/>
+            <a:ext cx="5029200" cy="4023360"/>
+          </a:xfrm>
+          <a:prstGeom prst="rect">
+            <a:avLst/>
+          </a:prstGeom>
+          <a:noFill/>
+        </p:spPr>
+        <p:txBody>
+          <a:bodyPr wrap="square" anchor="t">
+            <a:spAutoFit/>
+          </a:bodyPr>
+          <a:lstStyle/>
+          <a:p>
+            <a:pPr algn="l">
+              <a:lnSpc>
+                <a:spcPct val="108000"/>
+              </a:lnSpc>
+              <a:spcAft>
+                <a:spcPts val="1000"/>
+              </a:spcAft>
+            </a:pPr>
+            <a:r>
+              <a:rPr sz="1450" b="1" i="0">
+                <a:solidFill>
+                  <a:srgbClr val="EAF1F8"/>
+                </a:solidFill>
+                <a:latin typeface="Segoe UI"/>
+              </a:rPr>
+              <a:t>Risk desk + CrashLab (both shipped)</a:t>
+            </a:r>
+          </a:p>
+          <a:p>
+            <a:pPr algn="l">
+              <a:lnSpc>
+                <a:spcPct val="108000"/>
+              </a:lnSpc>
+              <a:spcAft>
+                <a:spcPts val="1000"/>
+              </a:spcAft>
+            </a:pPr>
+            <a:r>
+              <a:rPr sz="1200" b="0" i="0">
+                <a:solidFill>
+                  <a:srgbClr val="9FB0C0"/>
+                </a:solidFill>
+                <a:latin typeface="Segoe UI"/>
+              </a:rPr>
+              <a:t>A risk agent monitors the portfolio against the manager's own triggers and would trigger a rebalance; in v1 it is report-only, so the scored decision stays frozen. </a:t>
+            </a:r>
+            <a:r>
+              <a:rPr sz="1250" b="1" i="0">
+                <a:solidFill>
+                  <a:srgbClr val="1C8A5E"/>
+                </a:solidFill>
+                <a:latin typeface="Segoe UI"/>
+              </a:rPr>
+              <a:t>8/8 mechanical checks pass</a:t>
+            </a:r>
+            <a:r>
+              <a:rPr sz="1200" b="0" i="0">
+                <a:solidFill>
+                  <a:srgbClr val="9FB0C0"/>
+                </a:solidFill>
+                <a:latin typeface="Segoe UI"/>
+              </a:rPr>
+              <a:t>, and lessons from earlier runs feed back so the next portfolio avoids the same mistake.</a:t>
+            </a:r>
+          </a:p>
+          <a:p>
+            <a:pPr algn="l">
+              <a:lnSpc>
+                <a:spcPct val="108000"/>
+              </a:lnSpc>
+              <a:spcAft>
+                <a:spcPts val="1000"/>
+              </a:spcAft>
+            </a:pPr>
+            <a:r>
+              <a:rPr sz="1200" b="0" i="0">
+                <a:solidFill>
+                  <a:srgbClr val="9FB0C0"/>
+                </a:solidFill>
+                <a:latin typeface="Segoe UI"/>
+              </a:rPr>
+              <a:t>CrashLab replays the weights through 2008 (</a:t>
+            </a:r>
+            <a:r>
+              <a:rPr sz="1250" b="1" i="0">
+                <a:solidFill>
+                  <a:srgbClr val="D65A5A"/>
+                </a:solidFill>
+                <a:latin typeface="Segoe UI"/>
+              </a:rPr>
+              <a:t>-52%</a:t>
+            </a:r>
+            <a:r>
+              <a:rPr sz="1200" b="0" i="0">
+                <a:solidFill>
+                  <a:srgbClr val="9FB0C0"/>
+                </a:solidFill>
+                <a:latin typeface="Segoe UI"/>
+              </a:rPr>
+              <a:t>) and 2020 (</a:t>
+            </a:r>
+            <a:r>
+              <a:rPr sz="1250" b="1" i="0">
+                <a:solidFill>
+                  <a:srgbClr val="D65A5A"/>
+                </a:solidFill>
+                <a:latin typeface="Segoe UI"/>
+              </a:rPr>
+              <a:t>-27%</a:t>
+            </a:r>
+            <a:r>
+              <a:rPr sz="1200" b="0" i="0">
+                <a:solidFill>
+                  <a:srgbClr val="9FB0C0"/>
+                </a:solidFill>
+                <a:latin typeface="Segoe UI"/>
+              </a:rPr>
+              <a:t>) plus five invented shocks, then proposes protective trims with an explicit drawdown-removed vs return-given-up trade-off. The frozen decision never changes.</a:t>
+            </a:r>
+          </a:p>
+        </p:txBody>
+      </p:sp>
+      <p:sp>
+        <p:nvSpPr>
+          <p:cNvPr id="8" name="Rounded Rectangle 7"/>
+          <p:cNvSpPr/>
+          <p:nvPr/>
+        </p:nvSpPr>
+        <p:spPr>
+          <a:xfrm>
+            <a:off x="6172200" y="1371600"/>
+            <a:ext cx="5486400" cy="4160520"/>
+          </a:xfrm>
+          <a:prstGeom prst="roundRect">
+            <a:avLst>
+              <a:gd name="adj" fmla="val 5000"/>
+            </a:avLst>
+          </a:prstGeom>
+          <a:solidFill>
+            <a:srgbClr val="142438"/>
+          </a:solidFill>
+          <a:ln w="25400">
+            <a:solidFill>
+              <a:srgbClr val="1B5FA8"/>
+            </a:solidFill>
+          </a:ln>
+          <a:effectLst/>
+        </p:spPr>
+        <p:style>
+          <a:lnRef idx="1">
+            <a:schemeClr val="accent1"/>
+          </a:lnRef>
+          <a:fillRef idx="3">
+            <a:schemeClr val="accent1"/>
+          </a:fillRef>
+          <a:effectRef idx="2">
+            <a:schemeClr val="accent1"/>
+          </a:effectRef>
+          <a:fontRef idx="minor">
+            <a:schemeClr val="lt1"/>
+          </a:fontRef>
+        </p:style>
+        <p:txBody>
+          <a:bodyPr rtlCol="0" anchor="ctr"/>
+          <a:lstStyle/>
+          <a:p>
+            <a:pPr algn="ctr"/>
+          </a:p>
+        </p:txBody>
+      </p:sp>
+      <p:sp>
+        <p:nvSpPr>
+          <p:cNvPr id="9" name="TextBox 8"/>
+          <p:cNvSpPr txBox="1"/>
+          <p:nvPr/>
+        </p:nvSpPr>
+        <p:spPr>
+          <a:xfrm>
+            <a:off x="6400800" y="1481328"/>
+            <a:ext cx="5029200" cy="457200"/>
+          </a:xfrm>
+          <a:prstGeom prst="rect">
+            <a:avLst/>
+          </a:prstGeom>
+          <a:noFill/>
+        </p:spPr>
+        <p:txBody>
+          <a:bodyPr wrap="square" anchor="t">
+            <a:spAutoFit/>
+          </a:bodyPr>
+          <a:lstStyle/>
+          <a:p>
+            <a:pPr algn="l">
+              <a:spcAft>
+                <a:spcPts val="500"/>
+              </a:spcAft>
+            </a:pPr>
+            <a:r>
+              <a:rPr sz="1450" b="1" i="0">
+                <a:solidFill>
+                  <a:srgbClr val="EAF1F8"/>
+                </a:solidFill>
+                <a:latin typeface="Segoe UI"/>
+              </a:rPr>
+              <a:t>Why trust it, and where it goes next</a:t>
+            </a:r>
+          </a:p>
+        </p:txBody>
+      </p:sp>
+      <p:sp>
+        <p:nvSpPr>
+          <p:cNvPr id="10" name="TextBox 9"/>
+          <p:cNvSpPr txBox="1"/>
+          <p:nvPr/>
+        </p:nvSpPr>
+        <p:spPr>
+          <a:xfrm>
+            <a:off x="6400800" y="1965960"/>
+            <a:ext cx="5074920" cy="3474720"/>
+          </a:xfrm>
+          <a:prstGeom prst="rect">
+            <a:avLst/>
+          </a:prstGeom>
+          <a:noFill/>
+        </p:spPr>
+        <p:txBody>
+          <a:bodyPr wrap="square" anchor="t">
+            <a:spAutoFit/>
+          </a:bodyPr>
+          <a:lstStyle/>
+          <a:p>
+            <a:pPr algn="l">
+              <a:lnSpc>
+                <a:spcPct val="105000"/>
+              </a:lnSpc>
+              <a:spcAft>
+                <a:spcPts val="1100"/>
+              </a:spcAft>
+            </a:pPr>
+            <a:r>
+              <a:rPr sz="1250" b="1" i="0">
+                <a:solidFill>
+                  <a:srgbClr val="FF9900"/>
+                </a:solidFill>
+                <a:latin typeface="Segoe UI"/>
+              </a:rPr>
+              <a:t>▸  </a:t>
+            </a:r>
+            <a:r>
+              <a:rPr sz="1250" b="1" i="0">
+                <a:solidFill>
+                  <a:srgbClr val="EAF1F8"/>
+                </a:solidFill>
+                <a:latin typeface="Segoe UI"/>
+              </a:rPr>
+              <a:t>Reproducible. </a:t>
+            </a:r>
+            <a:r>
+              <a:rPr sz="1250" b="0" i="0">
+                <a:solidFill>
+                  <a:srgbClr val="9FB0C0"/>
+                </a:solidFill>
+                <a:latin typeface="Segoe UI"/>
+              </a:rPr>
+              <a:t>Every model call is cached; a fresh clone returns the same decision and metrics.</a:t>
+            </a:r>
+          </a:p>
+          <a:p>
+            <a:pPr algn="l">
+              <a:lnSpc>
+                <a:spcPct val="105000"/>
+              </a:lnSpc>
+              <a:spcAft>
+                <a:spcPts val="1100"/>
+              </a:spcAft>
+            </a:pPr>
+            <a:r>
+              <a:rPr sz="1250" b="1" i="0">
+                <a:solidFill>
+                  <a:srgbClr val="FF9900"/>
+                </a:solidFill>
+                <a:latin typeface="Segoe UI"/>
+              </a:rPr>
+              <a:t>▸  </a:t>
+            </a:r>
+            <a:r>
+              <a:rPr sz="1250" b="1" i="0">
+                <a:solidFill>
+                  <a:srgbClr val="EAF1F8"/>
+                </a:solidFill>
+                <a:latin typeface="Segoe UI"/>
+              </a:rPr>
+              <a:t>Honest limits. </a:t>
+            </a:r>
+            <a:r>
+              <a:rPr sz="1250" b="0" i="0">
+                <a:solidFill>
+                  <a:srgbClr val="9FB0C0"/>
+                </a:solidFill>
+                <a:latin typeface="Segoe UI"/>
+              </a:rPr>
+              <a:t>Model memory, a 180-day window, a curated sentiment fallback, FRED unreachable — all stated.</a:t>
+            </a:r>
+          </a:p>
+          <a:p>
+            <a:pPr algn="l">
+              <a:lnSpc>
+                <a:spcPct val="105000"/>
+              </a:lnSpc>
+              <a:spcAft>
+                <a:spcPts val="1100"/>
+              </a:spcAft>
+            </a:pPr>
+            <a:r>
+              <a:rPr sz="1250" b="1" i="0">
+                <a:solidFill>
+                  <a:srgbClr val="FF9900"/>
+                </a:solidFill>
+                <a:latin typeface="Segoe UI"/>
+              </a:rPr>
+              <a:t>▸  </a:t>
+            </a:r>
+            <a:r>
+              <a:rPr sz="1250" b="1" i="0">
+                <a:solidFill>
+                  <a:srgbClr val="EAF1F8"/>
+                </a:solidFill>
+                <a:latin typeface="Segoe UI"/>
+              </a:rPr>
+              <a:t>Graded. </a:t>
+            </a:r>
+            <a:r>
+              <a:rPr sz="1250" b="0" i="0">
+                <a:solidFill>
+                  <a:srgbClr val="9FB0C0"/>
+                </a:solidFill>
+                <a:latin typeface="Segoe UI"/>
+              </a:rPr>
+              <a:t>An analyst scorecard shows fundamentals and technical drove the result.</a:t>
+            </a:r>
+          </a:p>
+          <a:p>
+            <a:pPr algn="l">
+              <a:lnSpc>
+                <a:spcPct val="105000"/>
+              </a:lnSpc>
+              <a:spcAft>
+                <a:spcPts val="1100"/>
+              </a:spcAft>
+            </a:pPr>
+            <a:r>
+              <a:rPr sz="1250" b="1" i="0">
+                <a:solidFill>
+                  <a:srgbClr val="FF9900"/>
+                </a:solidFill>
+                <a:latin typeface="Segoe UI"/>
+              </a:rPr>
+              <a:t>▸  </a:t>
+            </a:r>
+            <a:r>
+              <a:rPr sz="1250" b="1" i="0">
+                <a:solidFill>
+                  <a:srgbClr val="EAF1F8"/>
+                </a:solidFill>
+                <a:latin typeface="Segoe UI"/>
+              </a:rPr>
+              <a:t>Next. </a:t>
+            </a:r>
+            <a:r>
+              <a:rPr sz="1250" b="0" i="0">
+                <a:solidFill>
+                  <a:srgbClr val="9FB0C0"/>
+                </a:solidFill>
+                <a:latin typeface="Segoe UI"/>
+              </a:rPr>
+              <a:t>Promote the risk agent to month-end rebalancing; widen the universe and window.</a:t>
+            </a:r>
+          </a:p>
+        </p:txBody>
+      </p:sp>
+      <p:sp>
+        <p:nvSpPr>
+          <p:cNvPr id="11" name="TextBox 10"/>
+          <p:cNvSpPr txBox="1"/>
+          <p:nvPr/>
+        </p:nvSpPr>
+        <p:spPr>
+          <a:xfrm>
+            <a:off x="502920" y="5715000"/>
+            <a:ext cx="11155680" cy="457200"/>
+          </a:xfrm>
+          <a:prstGeom prst="rect">
+            <a:avLst/>
+          </a:prstGeom>
+          <a:noFill/>
+        </p:spPr>
+        <p:txBody>
+          <a:bodyPr wrap="square" anchor="t">
+            <a:spAutoFit/>
+          </a:bodyPr>
+          <a:lstStyle/>
+          <a:p>
             <a:pPr algn="ctr">
               <a:spcAft>
-                <a:spcPts val="400"/>
+                <a:spcPts val="500"/>
               </a:spcAft>
             </a:pPr>
             <a:r>
@@ -6312,7 +8173,94 @@
                 </a:solidFill>
                 <a:latin typeface="Segoe UI"/>
               </a:rPr>
-              <a:t>Historical experiment, not financial advice.  Thanks — questions?</a:t>
+              <a:t>Historical experiment, not financial advice or a trading recommendation.    </a:t>
+            </a:r>
+            <a:r>
+              <a:rPr sz="1300" b="1" i="0">
+                <a:solidFill>
+                  <a:srgbClr val="FF9900"/>
+                </a:solidFill>
+                <a:latin typeface="Segoe UI"/>
+              </a:rPr>
+              <a:t>Thank you — questions?</a:t>
+            </a:r>
+          </a:p>
+        </p:txBody>
+      </p:sp>
+      <p:sp>
+        <p:nvSpPr>
+          <p:cNvPr id="12" name="TextBox 11"/>
+          <p:cNvSpPr txBox="1"/>
+          <p:nvPr/>
+        </p:nvSpPr>
+        <p:spPr>
+          <a:xfrm>
+            <a:off x="502920" y="6446520"/>
+            <a:ext cx="9144000" cy="274320"/>
+          </a:xfrm>
+          <a:prstGeom prst="rect">
+            <a:avLst/>
+          </a:prstGeom>
+          <a:noFill/>
+        </p:spPr>
+        <p:txBody>
+          <a:bodyPr wrap="square" anchor="t">
+            <a:spAutoFit/>
+          </a:bodyPr>
+          <a:lstStyle/>
+          <a:p>
+            <a:pPr algn="l">
+              <a:spcAft>
+                <a:spcPts val="500"/>
+              </a:spcAft>
+            </a:pPr>
+            <a:r>
+              <a:rPr sz="800" b="0" i="0">
+                <a:solidFill>
+                  <a:srgbClr val="5A6D80"/>
+                </a:solidFill>
+                <a:latin typeface="Segoe UI"/>
+              </a:rPr>
+              <a:t>Multi-agent portfolio research · Austin Agentic AI Hackathon · historical experiment, not financial advice</a:t>
+            </a:r>
+          </a:p>
+        </p:txBody>
+      </p:sp>
+      <p:sp>
+        <p:nvSpPr>
+          <p:cNvPr id="13" name="TextBox 12"/>
+          <p:cNvSpPr txBox="1"/>
+          <p:nvPr/>
+        </p:nvSpPr>
+        <p:spPr>
+          <a:xfrm>
+            <a:off x="11338560" y="6446520"/>
+            <a:ext cx="548640" cy="274320"/>
+          </a:xfrm>
+          <a:prstGeom prst="rect">
+            <a:avLst/>
+          </a:prstGeom>
+          <a:noFill/>
+        </p:spPr>
+        <p:txBody>
+          <a:bodyPr wrap="square" anchor="t">
+            <a:spAutoFit/>
+          </a:bodyPr>
+          <a:lstStyle/>
+          <a:p>
+            <a:pPr algn="r">
+              <a:spcAft>
+                <a:spcPts val="500"/>
+              </a:spcAft>
+            </a:pPr>
+            <a:r>
+              <a:rPr sz="900" b="0" i="0">
+                <a:solidFill>
+                  <a:srgbClr val="9FB0C0"/>
+                </a:solidFill>
+                <a:latin typeface="Segoe UI"/>
+              </a:rPr>
+              <a:t>5</a:t>
             </a:r>
           </a:p>
         </p:txBody>

</xml_diff>